<commit_message>
docs(poster): update DIGITEX2026 poster assets and add build scripts
Co-Authored-By: Claude Fable 5 <noreply@anthropic.com>
</commit_message>
<xml_diff>
--- a/docs/poster/MentorMinds-DIGITEX2026-poster.pptx
+++ b/docs/poster/MentorMinds-DIGITEX2026-poster.pptx
@@ -2,12 +2,12 @@
 <file path=ppt/presentation.xml><?xml version="1.0" encoding="utf-8"?>
 <p:presentation xmlns:a="http://schemas.openxmlformats.org/drawingml/2006/main" xmlns:r="http://schemas.openxmlformats.org/officeDocument/2006/relationships" xmlns:p="http://schemas.openxmlformats.org/presentationml/2006/main" saveSubsetFonts="1" autoCompressPictures="0">
   <p:sldMasterIdLst>
-    <p:sldMasterId id="2147483660" r:id="rId1"/>
+    <p:sldMasterId id="2147483648" r:id="rId1"/>
   </p:sldMasterIdLst>
   <p:sldIdLst>
-    <p:sldId id="256" r:id="rId2"/>
+    <p:sldId id="256" r:id="rId7"/>
   </p:sldIdLst>
-  <p:sldSz cx="21420138" cy="30275213"/>
+  <p:sldSz cx="21384000" cy="30276000" type="screen4x3"/>
   <p:notesSz cx="6858000" cy="9144000"/>
   <p:defaultTextStyle>
     <a:defPPr>
@@ -104,57 +104,7 @@
       </a:defRPr>
     </a:lvl9pPr>
   </p:defaultTextStyle>
-  <p:extLst>
-    <p:ext uri="{EFAFB233-063F-42B5-8137-9DF3F51BA10A}">
-      <p15:sldGuideLst xmlns:p15="http://schemas.microsoft.com/office/powerpoint/2012/main"/>
-    </p:ext>
-  </p:extLst>
 </p:presentation>
-</file>
-
-<file path=ppt/revisionInfo.xml><?xml version="1.0" encoding="utf-8"?>
-<p1510:revInfo xmlns:a="http://schemas.openxmlformats.org/drawingml/2006/main" xmlns:r="http://schemas.openxmlformats.org/officeDocument/2006/relationships" xmlns:p1510="http://schemas.microsoft.com/office/powerpoint/2015/10/main">
-  <p1510:revLst>
-    <p1510:client id="{37E6CD50-4D48-4664-A09B-79E1F16272AE}" v="1" dt="2025-05-10T19:35:43.131"/>
-  </p1510:revLst>
-</p1510:revInfo>
-</file>
-
-<file path=ppt/changesInfos/changesInfo1.xml><?xml version="1.0" encoding="utf-8"?>
-<pc:chgInfo xmlns:a="http://schemas.openxmlformats.org/drawingml/2006/main" xmlns:r="http://schemas.openxmlformats.org/officeDocument/2006/relationships" xmlns:ac="http://schemas.microsoft.com/office/drawing/2013/main/command" xmlns:pc="http://schemas.microsoft.com/office/powerpoint/2013/main/command">
-  <pc:docChgLst>
-    <pc:chgData name="ZUL AZRI BIN A. RAHMAN" userId="68eedd7a-e398-4a37-bff1-b4c8fffe1082" providerId="ADAL" clId="{37E6CD50-4D48-4664-A09B-79E1F16272AE}"/>
-    <pc:docChg chg="custSel modMainMaster">
-      <pc:chgData name="ZUL AZRI BIN A. RAHMAN" userId="68eedd7a-e398-4a37-bff1-b4c8fffe1082" providerId="ADAL" clId="{37E6CD50-4D48-4664-A09B-79E1F16272AE}" dt="2025-05-10T19:35:50.227" v="5" actId="1076"/>
-      <pc:docMkLst>
-        <pc:docMk/>
-      </pc:docMkLst>
-      <pc:sldMasterChg chg="addSp delSp modSp mod">
-        <pc:chgData name="ZUL AZRI BIN A. RAHMAN" userId="68eedd7a-e398-4a37-bff1-b4c8fffe1082" providerId="ADAL" clId="{37E6CD50-4D48-4664-A09B-79E1F16272AE}" dt="2025-05-10T19:35:50.227" v="5" actId="1076"/>
-        <pc:sldMasterMkLst>
-          <pc:docMk/>
-          <pc:sldMasterMk cId="730105992" sldId="2147483660"/>
-        </pc:sldMasterMkLst>
-        <pc:picChg chg="del">
-          <ac:chgData name="ZUL AZRI BIN A. RAHMAN" userId="68eedd7a-e398-4a37-bff1-b4c8fffe1082" providerId="ADAL" clId="{37E6CD50-4D48-4664-A09B-79E1F16272AE}" dt="2025-05-10T19:35:46.966" v="4" actId="478"/>
-          <ac:picMkLst>
-            <pc:docMk/>
-            <pc:sldMasterMk cId="730105992" sldId="2147483660"/>
-            <ac:picMk id="3" creationId="{70F6060A-C3D2-E36C-19BE-EFA008016357}"/>
-          </ac:picMkLst>
-        </pc:picChg>
-        <pc:picChg chg="add mod">
-          <ac:chgData name="ZUL AZRI BIN A. RAHMAN" userId="68eedd7a-e398-4a37-bff1-b4c8fffe1082" providerId="ADAL" clId="{37E6CD50-4D48-4664-A09B-79E1F16272AE}" dt="2025-05-10T19:35:50.227" v="5" actId="1076"/>
-          <ac:picMkLst>
-            <pc:docMk/>
-            <pc:sldMasterMk cId="730105992" sldId="2147483660"/>
-            <ac:picMk id="4" creationId="{C4700CC2-22A5-B3C5-7F9A-EF37312F779B}"/>
-          </ac:picMkLst>
-        </pc:picChg>
-      </pc:sldMasterChg>
-    </pc:docChg>
-  </pc:docChgLst>
-</pc:chgInfo>
 </file>
 
 <file path=ppt/slideLayouts/slideLayout1.xml><?xml version="1.0" encoding="utf-8"?>
@@ -186,26 +136,19 @@
         </p:nvSpPr>
         <p:spPr>
           <a:xfrm>
-            <a:off x="1606511" y="4954765"/>
-            <a:ext cx="18207117" cy="10540259"/>
+            <a:off x="685800" y="2130425"/>
+            <a:ext cx="7772400" cy="1470025"/>
           </a:xfrm>
-          <a:prstGeom prst="rect">
-            <a:avLst/>
-          </a:prstGeom>
         </p:spPr>
         <p:txBody>
-          <a:bodyPr anchor="b"/>
-          <a:lstStyle>
-            <a:lvl1pPr algn="ctr">
-              <a:defRPr sz="14055"/>
-            </a:lvl1pPr>
-          </a:lstStyle>
-          <a:p>
-            <a:r>
-              <a:rPr lang="en-GB" dirty="0"/>
+          <a:bodyPr/>
+          <a:lstStyle/>
+          <a:p>
+            <a:r>
+              <a:rPr lang="en-US" smtClean="0"/>
               <a:t>Click to edit Master title style</a:t>
             </a:r>
-            <a:endParaRPr lang="en-US" dirty="0"/>
+            <a:endParaRPr lang="en-US"/>
           </a:p>
         </p:txBody>
       </p:sp>
@@ -221,59 +164,110 @@
         </p:nvSpPr>
         <p:spPr>
           <a:xfrm>
-            <a:off x="2677517" y="15901497"/>
-            <a:ext cx="16065104" cy="7309499"/>
+            <a:off x="1371600" y="3886200"/>
+            <a:ext cx="6400800" cy="1752600"/>
           </a:xfrm>
-          <a:prstGeom prst="rect">
-            <a:avLst/>
-          </a:prstGeom>
         </p:spPr>
         <p:txBody>
           <a:bodyPr/>
           <a:lstStyle>
             <a:lvl1pPr marL="0" indent="0" algn="ctr">
               <a:buNone/>
-              <a:defRPr sz="5622"/>
+              <a:defRPr>
+                <a:solidFill>
+                  <a:schemeClr val="tx1">
+                    <a:tint val="75000"/>
+                  </a:schemeClr>
+                </a:solidFill>
+              </a:defRPr>
             </a:lvl1pPr>
-            <a:lvl2pPr marL="1070991" indent="0" algn="ctr">
-              <a:buNone/>
-              <a:defRPr sz="4685"/>
+            <a:lvl2pPr marL="457200" indent="0" algn="ctr">
+              <a:buNone/>
+              <a:defRPr>
+                <a:solidFill>
+                  <a:schemeClr val="tx1">
+                    <a:tint val="75000"/>
+                  </a:schemeClr>
+                </a:solidFill>
+              </a:defRPr>
             </a:lvl2pPr>
-            <a:lvl3pPr marL="2141982" indent="0" algn="ctr">
-              <a:buNone/>
-              <a:defRPr sz="4217"/>
+            <a:lvl3pPr marL="914400" indent="0" algn="ctr">
+              <a:buNone/>
+              <a:defRPr>
+                <a:solidFill>
+                  <a:schemeClr val="tx1">
+                    <a:tint val="75000"/>
+                  </a:schemeClr>
+                </a:solidFill>
+              </a:defRPr>
             </a:lvl3pPr>
-            <a:lvl4pPr marL="3212973" indent="0" algn="ctr">
-              <a:buNone/>
-              <a:defRPr sz="3748"/>
+            <a:lvl4pPr marL="1371600" indent="0" algn="ctr">
+              <a:buNone/>
+              <a:defRPr>
+                <a:solidFill>
+                  <a:schemeClr val="tx1">
+                    <a:tint val="75000"/>
+                  </a:schemeClr>
+                </a:solidFill>
+              </a:defRPr>
             </a:lvl4pPr>
-            <a:lvl5pPr marL="4283964" indent="0" algn="ctr">
-              <a:buNone/>
-              <a:defRPr sz="3748"/>
+            <a:lvl5pPr marL="1828800" indent="0" algn="ctr">
+              <a:buNone/>
+              <a:defRPr>
+                <a:solidFill>
+                  <a:schemeClr val="tx1">
+                    <a:tint val="75000"/>
+                  </a:schemeClr>
+                </a:solidFill>
+              </a:defRPr>
             </a:lvl5pPr>
-            <a:lvl6pPr marL="5354955" indent="0" algn="ctr">
-              <a:buNone/>
-              <a:defRPr sz="3748"/>
+            <a:lvl6pPr marL="2286000" indent="0" algn="ctr">
+              <a:buNone/>
+              <a:defRPr>
+                <a:solidFill>
+                  <a:schemeClr val="tx1">
+                    <a:tint val="75000"/>
+                  </a:schemeClr>
+                </a:solidFill>
+              </a:defRPr>
             </a:lvl6pPr>
-            <a:lvl7pPr marL="6425946" indent="0" algn="ctr">
-              <a:buNone/>
-              <a:defRPr sz="3748"/>
+            <a:lvl7pPr marL="2743200" indent="0" algn="ctr">
+              <a:buNone/>
+              <a:defRPr>
+                <a:solidFill>
+                  <a:schemeClr val="tx1">
+                    <a:tint val="75000"/>
+                  </a:schemeClr>
+                </a:solidFill>
+              </a:defRPr>
             </a:lvl7pPr>
-            <a:lvl8pPr marL="7496937" indent="0" algn="ctr">
-              <a:buNone/>
-              <a:defRPr sz="3748"/>
+            <a:lvl8pPr marL="3200400" indent="0" algn="ctr">
+              <a:buNone/>
+              <a:defRPr>
+                <a:solidFill>
+                  <a:schemeClr val="tx1">
+                    <a:tint val="75000"/>
+                  </a:schemeClr>
+                </a:solidFill>
+              </a:defRPr>
             </a:lvl8pPr>
-            <a:lvl9pPr marL="8567928" indent="0" algn="ctr">
-              <a:buNone/>
-              <a:defRPr sz="3748"/>
+            <a:lvl9pPr marL="3657600" indent="0" algn="ctr">
+              <a:buNone/>
+              <a:defRPr>
+                <a:solidFill>
+                  <a:schemeClr val="tx1">
+                    <a:tint val="75000"/>
+                  </a:schemeClr>
+                </a:solidFill>
+              </a:defRPr>
             </a:lvl9pPr>
           </a:lstStyle>
           <a:p>
             <a:r>
-              <a:rPr lang="en-GB"/>
+              <a:rPr lang="en-US" smtClean="0"/>
               <a:t>Click to edit Master subtitle style</a:t>
             </a:r>
-            <a:endParaRPr lang="en-US" dirty="0"/>
+            <a:endParaRPr lang="en-US"/>
           </a:p>
         </p:txBody>
       </p:sp>
@@ -287,22 +281,14 @@
             <p:ph type="dt" sz="half" idx="10"/>
           </p:nvPr>
         </p:nvSpPr>
-        <p:spPr>
-          <a:xfrm>
-            <a:off x="1472635" y="28060644"/>
-            <a:ext cx="4819531" cy="1611875"/>
-          </a:xfrm>
-          <a:prstGeom prst="rect">
-            <a:avLst/>
-          </a:prstGeom>
-        </p:spPr>
-        <p:txBody>
-          <a:bodyPr/>
-          <a:lstStyle/>
-          <a:p>
-            <a:fld id="{A18AD862-C623-2F4C-8F0F-0FC2EEA5CCAC}" type="datetimeFigureOut">
-              <a:rPr lang="en-US" smtClean="0"/>
-              <a:t>5/15/2026</a:t>
+        <p:spPr/>
+        <p:txBody>
+          <a:bodyPr/>
+          <a:lstStyle/>
+          <a:p>
+            <a:fld id="{5BCAD085-E8A6-8845-BD4E-CB4CCA059FC4}" type="datetimeFigureOut">
+              <a:rPr lang="en-US" smtClean="0"/>
+              <a:t>1/27/13</a:t>
             </a:fld>
             <a:endParaRPr lang="en-US"/>
           </a:p>
@@ -318,15 +304,7 @@
             <p:ph type="ftr" sz="quarter" idx="11"/>
           </p:nvPr>
         </p:nvSpPr>
-        <p:spPr>
-          <a:xfrm>
-            <a:off x="7095421" y="28060644"/>
-            <a:ext cx="7229297" cy="1611875"/>
-          </a:xfrm>
-          <a:prstGeom prst="rect">
-            <a:avLst/>
-          </a:prstGeom>
-        </p:spPr>
+        <p:spPr/>
         <p:txBody>
           <a:bodyPr/>
           <a:lstStyle/>
@@ -345,20 +323,12 @@
             <p:ph type="sldNum" sz="quarter" idx="12"/>
           </p:nvPr>
         </p:nvSpPr>
-        <p:spPr>
-          <a:xfrm>
-            <a:off x="15127972" y="28060644"/>
-            <a:ext cx="4819531" cy="1611875"/>
-          </a:xfrm>
-          <a:prstGeom prst="rect">
-            <a:avLst/>
-          </a:prstGeom>
-        </p:spPr>
-        <p:txBody>
-          <a:bodyPr/>
-          <a:lstStyle/>
-          <a:p>
-            <a:fld id="{CF2C3D6F-2254-F942-82E9-860973A72D47}" type="slidenum">
+        <p:spPr/>
+        <p:txBody>
+          <a:bodyPr/>
+          <a:lstStyle/>
+          <a:p>
+            <a:fld id="{C1FF6DA9-008F-8B48-92A6-B652298478BF}" type="slidenum">
               <a:rPr lang="en-US" smtClean="0"/>
               <a:t>‹#›</a:t>
             </a:fld>
@@ -369,7 +339,7 @@
     </p:spTree>
     <p:extLst>
       <p:ext uri="{BB962C8B-B14F-4D97-AF65-F5344CB8AC3E}">
-        <p14:creationId xmlns:p14="http://schemas.microsoft.com/office/powerpoint/2010/main" val="2116654608"/>
+        <p14:creationId xmlns:p14="http://schemas.microsoft.com/office/powerpoint/2010/main" val="3168075583"/>
       </p:ext>
     </p:extLst>
   </p:cSld>
@@ -406,24 +376,16 @@
             <p:ph type="title"/>
           </p:nvPr>
         </p:nvSpPr>
-        <p:spPr>
-          <a:xfrm>
-            <a:off x="1472635" y="1611882"/>
-            <a:ext cx="18474869" cy="5851808"/>
-          </a:xfrm>
-          <a:prstGeom prst="rect">
-            <a:avLst/>
-          </a:prstGeom>
-        </p:spPr>
-        <p:txBody>
-          <a:bodyPr/>
-          <a:lstStyle/>
-          <a:p>
-            <a:r>
-              <a:rPr lang="en-GB"/>
+        <p:spPr/>
+        <p:txBody>
+          <a:bodyPr/>
+          <a:lstStyle/>
+          <a:p>
+            <a:r>
+              <a:rPr lang="en-US" smtClean="0"/>
               <a:t>Click to edit Master title style</a:t>
             </a:r>
-            <a:endParaRPr lang="en-US" dirty="0"/>
+            <a:endParaRPr lang="en-US"/>
           </a:p>
         </p:txBody>
       </p:sp>
@@ -437,53 +399,45 @@
             <p:ph type="body" orient="vert" idx="1"/>
           </p:nvPr>
         </p:nvSpPr>
-        <p:spPr>
-          <a:xfrm>
-            <a:off x="1472635" y="8059374"/>
-            <a:ext cx="18474869" cy="19209345"/>
-          </a:xfrm>
-          <a:prstGeom prst="rect">
-            <a:avLst/>
-          </a:prstGeom>
-        </p:spPr>
+        <p:spPr/>
         <p:txBody>
           <a:bodyPr vert="eaVert"/>
           <a:lstStyle/>
           <a:p>
             <a:pPr lvl="0"/>
             <a:r>
-              <a:rPr lang="en-GB"/>
+              <a:rPr lang="en-US" smtClean="0"/>
               <a:t>Click to edit Master text styles</a:t>
             </a:r>
           </a:p>
           <a:p>
             <a:pPr lvl="1"/>
             <a:r>
-              <a:rPr lang="en-GB"/>
+              <a:rPr lang="en-US" smtClean="0"/>
               <a:t>Second level</a:t>
             </a:r>
           </a:p>
           <a:p>
             <a:pPr lvl="2"/>
             <a:r>
-              <a:rPr lang="en-GB"/>
+              <a:rPr lang="en-US" smtClean="0"/>
               <a:t>Third level</a:t>
             </a:r>
           </a:p>
           <a:p>
             <a:pPr lvl="3"/>
             <a:r>
-              <a:rPr lang="en-GB"/>
+              <a:rPr lang="en-US" smtClean="0"/>
               <a:t>Fourth level</a:t>
             </a:r>
           </a:p>
           <a:p>
             <a:pPr lvl="4"/>
             <a:r>
-              <a:rPr lang="en-GB"/>
+              <a:rPr lang="en-US" smtClean="0"/>
               <a:t>Fifth level</a:t>
             </a:r>
-            <a:endParaRPr lang="en-US" dirty="0"/>
+            <a:endParaRPr lang="en-US"/>
           </a:p>
         </p:txBody>
       </p:sp>
@@ -497,22 +451,14 @@
             <p:ph type="dt" sz="half" idx="10"/>
           </p:nvPr>
         </p:nvSpPr>
-        <p:spPr>
-          <a:xfrm>
-            <a:off x="1472635" y="28060644"/>
-            <a:ext cx="4819531" cy="1611875"/>
-          </a:xfrm>
-          <a:prstGeom prst="rect">
-            <a:avLst/>
-          </a:prstGeom>
-        </p:spPr>
-        <p:txBody>
-          <a:bodyPr/>
-          <a:lstStyle/>
-          <a:p>
-            <a:fld id="{A18AD862-C623-2F4C-8F0F-0FC2EEA5CCAC}" type="datetimeFigureOut">
-              <a:rPr lang="en-US" smtClean="0"/>
-              <a:t>5/15/2026</a:t>
+        <p:spPr/>
+        <p:txBody>
+          <a:bodyPr/>
+          <a:lstStyle/>
+          <a:p>
+            <a:fld id="{5BCAD085-E8A6-8845-BD4E-CB4CCA059FC4}" type="datetimeFigureOut">
+              <a:rPr lang="en-US" smtClean="0"/>
+              <a:t>1/27/13</a:t>
             </a:fld>
             <a:endParaRPr lang="en-US"/>
           </a:p>
@@ -528,15 +474,7 @@
             <p:ph type="ftr" sz="quarter" idx="11"/>
           </p:nvPr>
         </p:nvSpPr>
-        <p:spPr>
-          <a:xfrm>
-            <a:off x="7095421" y="28060644"/>
-            <a:ext cx="7229297" cy="1611875"/>
-          </a:xfrm>
-          <a:prstGeom prst="rect">
-            <a:avLst/>
-          </a:prstGeom>
-        </p:spPr>
+        <p:spPr/>
         <p:txBody>
           <a:bodyPr/>
           <a:lstStyle/>
@@ -555,20 +493,12 @@
             <p:ph type="sldNum" sz="quarter" idx="12"/>
           </p:nvPr>
         </p:nvSpPr>
-        <p:spPr>
-          <a:xfrm>
-            <a:off x="15127972" y="28060644"/>
-            <a:ext cx="4819531" cy="1611875"/>
-          </a:xfrm>
-          <a:prstGeom prst="rect">
-            <a:avLst/>
-          </a:prstGeom>
-        </p:spPr>
-        <p:txBody>
-          <a:bodyPr/>
-          <a:lstStyle/>
-          <a:p>
-            <a:fld id="{CF2C3D6F-2254-F942-82E9-860973A72D47}" type="slidenum">
+        <p:spPr/>
+        <p:txBody>
+          <a:bodyPr/>
+          <a:lstStyle/>
+          <a:p>
+            <a:fld id="{C1FF6DA9-008F-8B48-92A6-B652298478BF}" type="slidenum">
               <a:rPr lang="en-US" smtClean="0"/>
               <a:t>‹#›</a:t>
             </a:fld>
@@ -579,7 +509,7 @@
     </p:spTree>
     <p:extLst>
       <p:ext uri="{BB962C8B-B14F-4D97-AF65-F5344CB8AC3E}">
-        <p14:creationId xmlns:p14="http://schemas.microsoft.com/office/powerpoint/2010/main" val="530701164"/>
+        <p14:creationId xmlns:p14="http://schemas.microsoft.com/office/powerpoint/2010/main" val="2910927964"/>
       </p:ext>
     </p:extLst>
   </p:cSld>
@@ -618,22 +548,19 @@
         </p:nvSpPr>
         <p:spPr>
           <a:xfrm>
-            <a:off x="15328788" y="1611875"/>
-            <a:ext cx="4618717" cy="25656844"/>
+            <a:off x="6629400" y="274638"/>
+            <a:ext cx="2057400" cy="5851525"/>
           </a:xfrm>
-          <a:prstGeom prst="rect">
-            <a:avLst/>
-          </a:prstGeom>
         </p:spPr>
         <p:txBody>
           <a:bodyPr vert="eaVert"/>
           <a:lstStyle/>
           <a:p>
             <a:r>
-              <a:rPr lang="en-GB"/>
+              <a:rPr lang="en-US" smtClean="0"/>
               <a:t>Click to edit Master title style</a:t>
             </a:r>
-            <a:endParaRPr lang="en-US" dirty="0"/>
+            <a:endParaRPr lang="en-US"/>
           </a:p>
         </p:txBody>
       </p:sp>
@@ -649,12 +576,9 @@
         </p:nvSpPr>
         <p:spPr>
           <a:xfrm>
-            <a:off x="1472636" y="1611875"/>
-            <a:ext cx="13588400" cy="25656844"/>
+            <a:off x="457200" y="274638"/>
+            <a:ext cx="6019800" cy="5851525"/>
           </a:xfrm>
-          <a:prstGeom prst="rect">
-            <a:avLst/>
-          </a:prstGeom>
         </p:spPr>
         <p:txBody>
           <a:bodyPr vert="eaVert"/>
@@ -662,38 +586,38 @@
           <a:p>
             <a:pPr lvl="0"/>
             <a:r>
-              <a:rPr lang="en-GB"/>
+              <a:rPr lang="en-US" smtClean="0"/>
               <a:t>Click to edit Master text styles</a:t>
             </a:r>
           </a:p>
           <a:p>
             <a:pPr lvl="1"/>
             <a:r>
-              <a:rPr lang="en-GB"/>
+              <a:rPr lang="en-US" smtClean="0"/>
               <a:t>Second level</a:t>
             </a:r>
           </a:p>
           <a:p>
             <a:pPr lvl="2"/>
             <a:r>
-              <a:rPr lang="en-GB"/>
+              <a:rPr lang="en-US" smtClean="0"/>
               <a:t>Third level</a:t>
             </a:r>
           </a:p>
           <a:p>
             <a:pPr lvl="3"/>
             <a:r>
-              <a:rPr lang="en-GB"/>
+              <a:rPr lang="en-US" smtClean="0"/>
               <a:t>Fourth level</a:t>
             </a:r>
           </a:p>
           <a:p>
             <a:pPr lvl="4"/>
             <a:r>
-              <a:rPr lang="en-GB"/>
+              <a:rPr lang="en-US" smtClean="0"/>
               <a:t>Fifth level</a:t>
             </a:r>
-            <a:endParaRPr lang="en-US" dirty="0"/>
+            <a:endParaRPr lang="en-US"/>
           </a:p>
         </p:txBody>
       </p:sp>
@@ -707,22 +631,14 @@
             <p:ph type="dt" sz="half" idx="10"/>
           </p:nvPr>
         </p:nvSpPr>
-        <p:spPr>
-          <a:xfrm>
-            <a:off x="1472635" y="28060644"/>
-            <a:ext cx="4819531" cy="1611875"/>
-          </a:xfrm>
-          <a:prstGeom prst="rect">
-            <a:avLst/>
-          </a:prstGeom>
-        </p:spPr>
-        <p:txBody>
-          <a:bodyPr/>
-          <a:lstStyle/>
-          <a:p>
-            <a:fld id="{A18AD862-C623-2F4C-8F0F-0FC2EEA5CCAC}" type="datetimeFigureOut">
-              <a:rPr lang="en-US" smtClean="0"/>
-              <a:t>5/15/2026</a:t>
+        <p:spPr/>
+        <p:txBody>
+          <a:bodyPr/>
+          <a:lstStyle/>
+          <a:p>
+            <a:fld id="{5BCAD085-E8A6-8845-BD4E-CB4CCA059FC4}" type="datetimeFigureOut">
+              <a:rPr lang="en-US" smtClean="0"/>
+              <a:t>1/27/13</a:t>
             </a:fld>
             <a:endParaRPr lang="en-US"/>
           </a:p>
@@ -738,15 +654,7 @@
             <p:ph type="ftr" sz="quarter" idx="11"/>
           </p:nvPr>
         </p:nvSpPr>
-        <p:spPr>
-          <a:xfrm>
-            <a:off x="7095421" y="28060644"/>
-            <a:ext cx="7229297" cy="1611875"/>
-          </a:xfrm>
-          <a:prstGeom prst="rect">
-            <a:avLst/>
-          </a:prstGeom>
-        </p:spPr>
+        <p:spPr/>
         <p:txBody>
           <a:bodyPr/>
           <a:lstStyle/>
@@ -765,20 +673,12 @@
             <p:ph type="sldNum" sz="quarter" idx="12"/>
           </p:nvPr>
         </p:nvSpPr>
-        <p:spPr>
-          <a:xfrm>
-            <a:off x="15127972" y="28060644"/>
-            <a:ext cx="4819531" cy="1611875"/>
-          </a:xfrm>
-          <a:prstGeom prst="rect">
-            <a:avLst/>
-          </a:prstGeom>
-        </p:spPr>
-        <p:txBody>
-          <a:bodyPr/>
-          <a:lstStyle/>
-          <a:p>
-            <a:fld id="{CF2C3D6F-2254-F942-82E9-860973A72D47}" type="slidenum">
+        <p:spPr/>
+        <p:txBody>
+          <a:bodyPr/>
+          <a:lstStyle/>
+          <a:p>
+            <a:fld id="{C1FF6DA9-008F-8B48-92A6-B652298478BF}" type="slidenum">
               <a:rPr lang="en-US" smtClean="0"/>
               <a:t>‹#›</a:t>
             </a:fld>
@@ -789,7 +689,7 @@
     </p:spTree>
     <p:extLst>
       <p:ext uri="{BB962C8B-B14F-4D97-AF65-F5344CB8AC3E}">
-        <p14:creationId xmlns:p14="http://schemas.microsoft.com/office/powerpoint/2010/main" val="744606519"/>
+        <p14:creationId xmlns:p14="http://schemas.microsoft.com/office/powerpoint/2010/main" val="3612223792"/>
       </p:ext>
     </p:extLst>
   </p:cSld>
@@ -826,24 +726,16 @@
             <p:ph type="title"/>
           </p:nvPr>
         </p:nvSpPr>
-        <p:spPr>
-          <a:xfrm>
-            <a:off x="1472635" y="1611882"/>
-            <a:ext cx="18474869" cy="5851808"/>
-          </a:xfrm>
-          <a:prstGeom prst="rect">
-            <a:avLst/>
-          </a:prstGeom>
-        </p:spPr>
-        <p:txBody>
-          <a:bodyPr/>
-          <a:lstStyle/>
-          <a:p>
-            <a:r>
-              <a:rPr lang="en-GB"/>
+        <p:spPr/>
+        <p:txBody>
+          <a:bodyPr/>
+          <a:lstStyle/>
+          <a:p>
+            <a:r>
+              <a:rPr lang="en-US" smtClean="0"/>
               <a:t>Click to edit Master title style</a:t>
             </a:r>
-            <a:endParaRPr lang="en-US" dirty="0"/>
+            <a:endParaRPr lang="en-US"/>
           </a:p>
         </p:txBody>
       </p:sp>
@@ -857,53 +749,45 @@
             <p:ph idx="1"/>
           </p:nvPr>
         </p:nvSpPr>
-        <p:spPr>
-          <a:xfrm>
-            <a:off x="1472635" y="8059374"/>
-            <a:ext cx="18474869" cy="19209345"/>
-          </a:xfrm>
-          <a:prstGeom prst="rect">
-            <a:avLst/>
-          </a:prstGeom>
-        </p:spPr>
+        <p:spPr/>
         <p:txBody>
           <a:bodyPr/>
           <a:lstStyle/>
           <a:p>
             <a:pPr lvl="0"/>
             <a:r>
-              <a:rPr lang="en-GB"/>
+              <a:rPr lang="en-US" smtClean="0"/>
               <a:t>Click to edit Master text styles</a:t>
             </a:r>
           </a:p>
           <a:p>
             <a:pPr lvl="1"/>
             <a:r>
-              <a:rPr lang="en-GB"/>
+              <a:rPr lang="en-US" smtClean="0"/>
               <a:t>Second level</a:t>
             </a:r>
           </a:p>
           <a:p>
             <a:pPr lvl="2"/>
             <a:r>
-              <a:rPr lang="en-GB"/>
+              <a:rPr lang="en-US" smtClean="0"/>
               <a:t>Third level</a:t>
             </a:r>
           </a:p>
           <a:p>
             <a:pPr lvl="3"/>
             <a:r>
-              <a:rPr lang="en-GB"/>
+              <a:rPr lang="en-US" smtClean="0"/>
               <a:t>Fourth level</a:t>
             </a:r>
           </a:p>
           <a:p>
             <a:pPr lvl="4"/>
             <a:r>
-              <a:rPr lang="en-GB"/>
+              <a:rPr lang="en-US" smtClean="0"/>
               <a:t>Fifth level</a:t>
             </a:r>
-            <a:endParaRPr lang="en-US" dirty="0"/>
+            <a:endParaRPr lang="en-US"/>
           </a:p>
         </p:txBody>
       </p:sp>
@@ -917,22 +801,14 @@
             <p:ph type="dt" sz="half" idx="10"/>
           </p:nvPr>
         </p:nvSpPr>
-        <p:spPr>
-          <a:xfrm>
-            <a:off x="1472635" y="28060644"/>
-            <a:ext cx="4819531" cy="1611875"/>
-          </a:xfrm>
-          <a:prstGeom prst="rect">
-            <a:avLst/>
-          </a:prstGeom>
-        </p:spPr>
-        <p:txBody>
-          <a:bodyPr/>
-          <a:lstStyle/>
-          <a:p>
-            <a:fld id="{A18AD862-C623-2F4C-8F0F-0FC2EEA5CCAC}" type="datetimeFigureOut">
-              <a:rPr lang="en-US" smtClean="0"/>
-              <a:t>5/15/2026</a:t>
+        <p:spPr/>
+        <p:txBody>
+          <a:bodyPr/>
+          <a:lstStyle/>
+          <a:p>
+            <a:fld id="{5BCAD085-E8A6-8845-BD4E-CB4CCA059FC4}" type="datetimeFigureOut">
+              <a:rPr lang="en-US" smtClean="0"/>
+              <a:t>1/27/13</a:t>
             </a:fld>
             <a:endParaRPr lang="en-US"/>
           </a:p>
@@ -948,15 +824,7 @@
             <p:ph type="ftr" sz="quarter" idx="11"/>
           </p:nvPr>
         </p:nvSpPr>
-        <p:spPr>
-          <a:xfrm>
-            <a:off x="7095421" y="28060644"/>
-            <a:ext cx="7229297" cy="1611875"/>
-          </a:xfrm>
-          <a:prstGeom prst="rect">
-            <a:avLst/>
-          </a:prstGeom>
-        </p:spPr>
+        <p:spPr/>
         <p:txBody>
           <a:bodyPr/>
           <a:lstStyle/>
@@ -975,20 +843,12 @@
             <p:ph type="sldNum" sz="quarter" idx="12"/>
           </p:nvPr>
         </p:nvSpPr>
-        <p:spPr>
-          <a:xfrm>
-            <a:off x="15127972" y="28060644"/>
-            <a:ext cx="4819531" cy="1611875"/>
-          </a:xfrm>
-          <a:prstGeom prst="rect">
-            <a:avLst/>
-          </a:prstGeom>
-        </p:spPr>
-        <p:txBody>
-          <a:bodyPr/>
-          <a:lstStyle/>
-          <a:p>
-            <a:fld id="{CF2C3D6F-2254-F942-82E9-860973A72D47}" type="slidenum">
+        <p:spPr/>
+        <p:txBody>
+          <a:bodyPr/>
+          <a:lstStyle/>
+          <a:p>
+            <a:fld id="{C1FF6DA9-008F-8B48-92A6-B652298478BF}" type="slidenum">
               <a:rPr lang="en-US" smtClean="0"/>
               <a:t>‹#›</a:t>
             </a:fld>
@@ -999,7 +859,7 @@
     </p:spTree>
     <p:extLst>
       <p:ext uri="{BB962C8B-B14F-4D97-AF65-F5344CB8AC3E}">
-        <p14:creationId xmlns:p14="http://schemas.microsoft.com/office/powerpoint/2010/main" val="3200274166"/>
+        <p14:creationId xmlns:p14="http://schemas.microsoft.com/office/powerpoint/2010/main" val="2614314258"/>
       </p:ext>
     </p:extLst>
   </p:cSld>
@@ -1038,137 +898,131 @@
         </p:nvSpPr>
         <p:spPr>
           <a:xfrm>
-            <a:off x="1461479" y="7547788"/>
-            <a:ext cx="18474869" cy="12593645"/>
+            <a:off x="722313" y="4406900"/>
+            <a:ext cx="7772400" cy="1362075"/>
           </a:xfrm>
-          <a:prstGeom prst="rect">
-            <a:avLst/>
-          </a:prstGeom>
+        </p:spPr>
+        <p:txBody>
+          <a:bodyPr anchor="t"/>
+          <a:lstStyle>
+            <a:lvl1pPr algn="l">
+              <a:defRPr sz="4000" b="1" cap="all"/>
+            </a:lvl1pPr>
+          </a:lstStyle>
+          <a:p>
+            <a:r>
+              <a:rPr lang="en-US" smtClean="0"/>
+              <a:t>Click to edit Master title style</a:t>
+            </a:r>
+            <a:endParaRPr lang="en-US"/>
+          </a:p>
+        </p:txBody>
+      </p:sp>
+      <p:sp>
+        <p:nvSpPr>
+          <p:cNvPr id="3" name="Text Placeholder 2"/>
+          <p:cNvSpPr>
+            <a:spLocks noGrp="1"/>
+          </p:cNvSpPr>
+          <p:nvPr>
+            <p:ph type="body" idx="1"/>
+          </p:nvPr>
+        </p:nvSpPr>
+        <p:spPr>
+          <a:xfrm>
+            <a:off x="722313" y="2906713"/>
+            <a:ext cx="7772400" cy="1500187"/>
+          </a:xfrm>
         </p:spPr>
         <p:txBody>
           <a:bodyPr anchor="b"/>
           <a:lstStyle>
-            <a:lvl1pPr>
-              <a:defRPr sz="14055"/>
-            </a:lvl1pPr>
-          </a:lstStyle>
-          <a:p>
-            <a:r>
-              <a:rPr lang="en-GB"/>
-              <a:t>Click to edit Master title style</a:t>
-            </a:r>
-            <a:endParaRPr lang="en-US" dirty="0"/>
-          </a:p>
-        </p:txBody>
-      </p:sp>
-      <p:sp>
-        <p:nvSpPr>
-          <p:cNvPr id="3" name="Text Placeholder 2"/>
-          <p:cNvSpPr>
-            <a:spLocks noGrp="1"/>
-          </p:cNvSpPr>
-          <p:nvPr>
-            <p:ph type="body" idx="1"/>
-          </p:nvPr>
-        </p:nvSpPr>
-        <p:spPr>
-          <a:xfrm>
-            <a:off x="1461479" y="20260574"/>
-            <a:ext cx="18474869" cy="6622701"/>
-          </a:xfrm>
-          <a:prstGeom prst="rect">
-            <a:avLst/>
-          </a:prstGeom>
-        </p:spPr>
-        <p:txBody>
-          <a:bodyPr/>
-          <a:lstStyle>
             <a:lvl1pPr marL="0" indent="0">
               <a:buNone/>
-              <a:defRPr sz="5622">
+              <a:defRPr sz="2000">
                 <a:solidFill>
                   <a:schemeClr val="tx1">
-                    <a:tint val="82000"/>
+                    <a:tint val="75000"/>
                   </a:schemeClr>
                 </a:solidFill>
               </a:defRPr>
             </a:lvl1pPr>
-            <a:lvl2pPr marL="1070991" indent="0">
-              <a:buNone/>
-              <a:defRPr sz="4685">
+            <a:lvl2pPr marL="457200" indent="0">
+              <a:buNone/>
+              <a:defRPr sz="1800">
                 <a:solidFill>
                   <a:schemeClr val="tx1">
-                    <a:tint val="82000"/>
+                    <a:tint val="75000"/>
                   </a:schemeClr>
                 </a:solidFill>
               </a:defRPr>
             </a:lvl2pPr>
-            <a:lvl3pPr marL="2141982" indent="0">
-              <a:buNone/>
-              <a:defRPr sz="4217">
+            <a:lvl3pPr marL="914400" indent="0">
+              <a:buNone/>
+              <a:defRPr sz="1600">
                 <a:solidFill>
                   <a:schemeClr val="tx1">
-                    <a:tint val="82000"/>
+                    <a:tint val="75000"/>
                   </a:schemeClr>
                 </a:solidFill>
               </a:defRPr>
             </a:lvl3pPr>
-            <a:lvl4pPr marL="3212973" indent="0">
-              <a:buNone/>
-              <a:defRPr sz="3748">
+            <a:lvl4pPr marL="1371600" indent="0">
+              <a:buNone/>
+              <a:defRPr sz="1400">
                 <a:solidFill>
                   <a:schemeClr val="tx1">
-                    <a:tint val="82000"/>
+                    <a:tint val="75000"/>
                   </a:schemeClr>
                 </a:solidFill>
               </a:defRPr>
             </a:lvl4pPr>
-            <a:lvl5pPr marL="4283964" indent="0">
-              <a:buNone/>
-              <a:defRPr sz="3748">
+            <a:lvl5pPr marL="1828800" indent="0">
+              <a:buNone/>
+              <a:defRPr sz="1400">
                 <a:solidFill>
                   <a:schemeClr val="tx1">
-                    <a:tint val="82000"/>
+                    <a:tint val="75000"/>
                   </a:schemeClr>
                 </a:solidFill>
               </a:defRPr>
             </a:lvl5pPr>
-            <a:lvl6pPr marL="5354955" indent="0">
-              <a:buNone/>
-              <a:defRPr sz="3748">
+            <a:lvl6pPr marL="2286000" indent="0">
+              <a:buNone/>
+              <a:defRPr sz="1400">
                 <a:solidFill>
                   <a:schemeClr val="tx1">
-                    <a:tint val="82000"/>
+                    <a:tint val="75000"/>
                   </a:schemeClr>
                 </a:solidFill>
               </a:defRPr>
             </a:lvl6pPr>
-            <a:lvl7pPr marL="6425946" indent="0">
-              <a:buNone/>
-              <a:defRPr sz="3748">
+            <a:lvl7pPr marL="2743200" indent="0">
+              <a:buNone/>
+              <a:defRPr sz="1400">
                 <a:solidFill>
                   <a:schemeClr val="tx1">
-                    <a:tint val="82000"/>
+                    <a:tint val="75000"/>
                   </a:schemeClr>
                 </a:solidFill>
               </a:defRPr>
             </a:lvl7pPr>
-            <a:lvl8pPr marL="7496937" indent="0">
-              <a:buNone/>
-              <a:defRPr sz="3748">
+            <a:lvl8pPr marL="3200400" indent="0">
+              <a:buNone/>
+              <a:defRPr sz="1400">
                 <a:solidFill>
                   <a:schemeClr val="tx1">
-                    <a:tint val="82000"/>
+                    <a:tint val="75000"/>
                   </a:schemeClr>
                 </a:solidFill>
               </a:defRPr>
             </a:lvl8pPr>
-            <a:lvl9pPr marL="8567928" indent="0">
-              <a:buNone/>
-              <a:defRPr sz="3748">
+            <a:lvl9pPr marL="3657600" indent="0">
+              <a:buNone/>
+              <a:defRPr sz="1400">
                 <a:solidFill>
                   <a:schemeClr val="tx1">
-                    <a:tint val="82000"/>
+                    <a:tint val="75000"/>
                   </a:schemeClr>
                 </a:solidFill>
               </a:defRPr>
@@ -1177,7 +1031,7 @@
           <a:p>
             <a:pPr lvl="0"/>
             <a:r>
-              <a:rPr lang="en-GB"/>
+              <a:rPr lang="en-US" smtClean="0"/>
               <a:t>Click to edit Master text styles</a:t>
             </a:r>
           </a:p>
@@ -1193,22 +1047,14 @@
             <p:ph type="dt" sz="half" idx="10"/>
           </p:nvPr>
         </p:nvSpPr>
-        <p:spPr>
-          <a:xfrm>
-            <a:off x="1472635" y="28060644"/>
-            <a:ext cx="4819531" cy="1611875"/>
-          </a:xfrm>
-          <a:prstGeom prst="rect">
-            <a:avLst/>
-          </a:prstGeom>
-        </p:spPr>
-        <p:txBody>
-          <a:bodyPr/>
-          <a:lstStyle/>
-          <a:p>
-            <a:fld id="{A18AD862-C623-2F4C-8F0F-0FC2EEA5CCAC}" type="datetimeFigureOut">
-              <a:rPr lang="en-US" smtClean="0"/>
-              <a:t>5/15/2026</a:t>
+        <p:spPr/>
+        <p:txBody>
+          <a:bodyPr/>
+          <a:lstStyle/>
+          <a:p>
+            <a:fld id="{5BCAD085-E8A6-8845-BD4E-CB4CCA059FC4}" type="datetimeFigureOut">
+              <a:rPr lang="en-US" smtClean="0"/>
+              <a:t>1/27/13</a:t>
             </a:fld>
             <a:endParaRPr lang="en-US"/>
           </a:p>
@@ -1224,15 +1070,7 @@
             <p:ph type="ftr" sz="quarter" idx="11"/>
           </p:nvPr>
         </p:nvSpPr>
-        <p:spPr>
-          <a:xfrm>
-            <a:off x="7095421" y="28060644"/>
-            <a:ext cx="7229297" cy="1611875"/>
-          </a:xfrm>
-          <a:prstGeom prst="rect">
-            <a:avLst/>
-          </a:prstGeom>
-        </p:spPr>
+        <p:spPr/>
         <p:txBody>
           <a:bodyPr/>
           <a:lstStyle/>
@@ -1251,20 +1089,12 @@
             <p:ph type="sldNum" sz="quarter" idx="12"/>
           </p:nvPr>
         </p:nvSpPr>
-        <p:spPr>
-          <a:xfrm>
-            <a:off x="15127972" y="28060644"/>
-            <a:ext cx="4819531" cy="1611875"/>
-          </a:xfrm>
-          <a:prstGeom prst="rect">
-            <a:avLst/>
-          </a:prstGeom>
-        </p:spPr>
-        <p:txBody>
-          <a:bodyPr/>
-          <a:lstStyle/>
-          <a:p>
-            <a:fld id="{CF2C3D6F-2254-F942-82E9-860973A72D47}" type="slidenum">
+        <p:spPr/>
+        <p:txBody>
+          <a:bodyPr/>
+          <a:lstStyle/>
+          <a:p>
+            <a:fld id="{C1FF6DA9-008F-8B48-92A6-B652298478BF}" type="slidenum">
               <a:rPr lang="en-US" smtClean="0"/>
               <a:t>‹#›</a:t>
             </a:fld>
@@ -1275,7 +1105,7 @@
     </p:spTree>
     <p:extLst>
       <p:ext uri="{BB962C8B-B14F-4D97-AF65-F5344CB8AC3E}">
-        <p14:creationId xmlns:p14="http://schemas.microsoft.com/office/powerpoint/2010/main" val="3554248050"/>
+        <p14:creationId xmlns:p14="http://schemas.microsoft.com/office/powerpoint/2010/main" val="960648375"/>
       </p:ext>
     </p:extLst>
   </p:cSld>
@@ -1312,144 +1142,186 @@
             <p:ph type="title"/>
           </p:nvPr>
         </p:nvSpPr>
+        <p:spPr/>
+        <p:txBody>
+          <a:bodyPr/>
+          <a:lstStyle/>
+          <a:p>
+            <a:r>
+              <a:rPr lang="en-US" smtClean="0"/>
+              <a:t>Click to edit Master title style</a:t>
+            </a:r>
+            <a:endParaRPr lang="en-US"/>
+          </a:p>
+        </p:txBody>
+      </p:sp>
+      <p:sp>
+        <p:nvSpPr>
+          <p:cNvPr id="3" name="Content Placeholder 2"/>
+          <p:cNvSpPr>
+            <a:spLocks noGrp="1"/>
+          </p:cNvSpPr>
+          <p:nvPr>
+            <p:ph sz="half" idx="1"/>
+          </p:nvPr>
+        </p:nvSpPr>
         <p:spPr>
           <a:xfrm>
-            <a:off x="1472635" y="1611882"/>
-            <a:ext cx="18474869" cy="5851808"/>
+            <a:off x="457200" y="1600200"/>
+            <a:ext cx="4038600" cy="4525963"/>
           </a:xfrm>
-          <a:prstGeom prst="rect">
-            <a:avLst/>
-          </a:prstGeom>
         </p:spPr>
         <p:txBody>
           <a:bodyPr/>
-          <a:lstStyle/>
-          <a:p>
-            <a:r>
-              <a:rPr lang="en-GB"/>
-              <a:t>Click to edit Master title style</a:t>
-            </a:r>
-            <a:endParaRPr lang="en-US" dirty="0"/>
-          </a:p>
-        </p:txBody>
-      </p:sp>
-      <p:sp>
-        <p:nvSpPr>
-          <p:cNvPr id="3" name="Content Placeholder 2"/>
-          <p:cNvSpPr>
-            <a:spLocks noGrp="1"/>
-          </p:cNvSpPr>
-          <p:nvPr>
-            <p:ph sz="half" idx="1"/>
+          <a:lstStyle>
+            <a:lvl1pPr>
+              <a:defRPr sz="2800"/>
+            </a:lvl1pPr>
+            <a:lvl2pPr>
+              <a:defRPr sz="2400"/>
+            </a:lvl2pPr>
+            <a:lvl3pPr>
+              <a:defRPr sz="2000"/>
+            </a:lvl3pPr>
+            <a:lvl4pPr>
+              <a:defRPr sz="1800"/>
+            </a:lvl4pPr>
+            <a:lvl5pPr>
+              <a:defRPr sz="1800"/>
+            </a:lvl5pPr>
+            <a:lvl6pPr>
+              <a:defRPr sz="1800"/>
+            </a:lvl6pPr>
+            <a:lvl7pPr>
+              <a:defRPr sz="1800"/>
+            </a:lvl7pPr>
+            <a:lvl8pPr>
+              <a:defRPr sz="1800"/>
+            </a:lvl8pPr>
+            <a:lvl9pPr>
+              <a:defRPr sz="1800"/>
+            </a:lvl9pPr>
+          </a:lstStyle>
+          <a:p>
+            <a:pPr lvl="0"/>
+            <a:r>
+              <a:rPr lang="en-US" smtClean="0"/>
+              <a:t>Click to edit Master text styles</a:t>
+            </a:r>
+          </a:p>
+          <a:p>
+            <a:pPr lvl="1"/>
+            <a:r>
+              <a:rPr lang="en-US" smtClean="0"/>
+              <a:t>Second level</a:t>
+            </a:r>
+          </a:p>
+          <a:p>
+            <a:pPr lvl="2"/>
+            <a:r>
+              <a:rPr lang="en-US" smtClean="0"/>
+              <a:t>Third level</a:t>
+            </a:r>
+          </a:p>
+          <a:p>
+            <a:pPr lvl="3"/>
+            <a:r>
+              <a:rPr lang="en-US" smtClean="0"/>
+              <a:t>Fourth level</a:t>
+            </a:r>
+          </a:p>
+          <a:p>
+            <a:pPr lvl="4"/>
+            <a:r>
+              <a:rPr lang="en-US" smtClean="0"/>
+              <a:t>Fifth level</a:t>
+            </a:r>
+            <a:endParaRPr lang="en-US"/>
+          </a:p>
+        </p:txBody>
+      </p:sp>
+      <p:sp>
+        <p:nvSpPr>
+          <p:cNvPr id="4" name="Content Placeholder 3"/>
+          <p:cNvSpPr>
+            <a:spLocks noGrp="1"/>
+          </p:cNvSpPr>
+          <p:nvPr>
+            <p:ph sz="half" idx="2"/>
           </p:nvPr>
         </p:nvSpPr>
         <p:spPr>
           <a:xfrm>
-            <a:off x="1472634" y="8059374"/>
-            <a:ext cx="9103559" cy="19209345"/>
+            <a:off x="4648200" y="1600200"/>
+            <a:ext cx="4038600" cy="4525963"/>
           </a:xfrm>
-          <a:prstGeom prst="rect">
-            <a:avLst/>
-          </a:prstGeom>
         </p:spPr>
         <p:txBody>
           <a:bodyPr/>
-          <a:lstStyle/>
+          <a:lstStyle>
+            <a:lvl1pPr>
+              <a:defRPr sz="2800"/>
+            </a:lvl1pPr>
+            <a:lvl2pPr>
+              <a:defRPr sz="2400"/>
+            </a:lvl2pPr>
+            <a:lvl3pPr>
+              <a:defRPr sz="2000"/>
+            </a:lvl3pPr>
+            <a:lvl4pPr>
+              <a:defRPr sz="1800"/>
+            </a:lvl4pPr>
+            <a:lvl5pPr>
+              <a:defRPr sz="1800"/>
+            </a:lvl5pPr>
+            <a:lvl6pPr>
+              <a:defRPr sz="1800"/>
+            </a:lvl6pPr>
+            <a:lvl7pPr>
+              <a:defRPr sz="1800"/>
+            </a:lvl7pPr>
+            <a:lvl8pPr>
+              <a:defRPr sz="1800"/>
+            </a:lvl8pPr>
+            <a:lvl9pPr>
+              <a:defRPr sz="1800"/>
+            </a:lvl9pPr>
+          </a:lstStyle>
           <a:p>
             <a:pPr lvl="0"/>
             <a:r>
-              <a:rPr lang="en-GB"/>
+              <a:rPr lang="en-US" smtClean="0"/>
               <a:t>Click to edit Master text styles</a:t>
             </a:r>
           </a:p>
           <a:p>
             <a:pPr lvl="1"/>
             <a:r>
-              <a:rPr lang="en-GB"/>
+              <a:rPr lang="en-US" smtClean="0"/>
               <a:t>Second level</a:t>
             </a:r>
           </a:p>
           <a:p>
             <a:pPr lvl="2"/>
             <a:r>
-              <a:rPr lang="en-GB"/>
+              <a:rPr lang="en-US" smtClean="0"/>
               <a:t>Third level</a:t>
             </a:r>
           </a:p>
           <a:p>
             <a:pPr lvl="3"/>
             <a:r>
-              <a:rPr lang="en-GB"/>
+              <a:rPr lang="en-US" smtClean="0"/>
               <a:t>Fourth level</a:t>
             </a:r>
           </a:p>
           <a:p>
             <a:pPr lvl="4"/>
             <a:r>
-              <a:rPr lang="en-GB"/>
+              <a:rPr lang="en-US" smtClean="0"/>
               <a:t>Fifth level</a:t>
             </a:r>
-            <a:endParaRPr lang="en-US" dirty="0"/>
-          </a:p>
-        </p:txBody>
-      </p:sp>
-      <p:sp>
-        <p:nvSpPr>
-          <p:cNvPr id="4" name="Content Placeholder 3"/>
-          <p:cNvSpPr>
-            <a:spLocks noGrp="1"/>
-          </p:cNvSpPr>
-          <p:nvPr>
-            <p:ph sz="half" idx="2"/>
-          </p:nvPr>
-        </p:nvSpPr>
-        <p:spPr>
-          <a:xfrm>
-            <a:off x="10843945" y="8059374"/>
-            <a:ext cx="9103559" cy="19209345"/>
-          </a:xfrm>
-          <a:prstGeom prst="rect">
-            <a:avLst/>
-          </a:prstGeom>
-        </p:spPr>
-        <p:txBody>
-          <a:bodyPr/>
-          <a:lstStyle/>
-          <a:p>
-            <a:pPr lvl="0"/>
-            <a:r>
-              <a:rPr lang="en-GB"/>
-              <a:t>Click to edit Master text styles</a:t>
-            </a:r>
-          </a:p>
-          <a:p>
-            <a:pPr lvl="1"/>
-            <a:r>
-              <a:rPr lang="en-GB"/>
-              <a:t>Second level</a:t>
-            </a:r>
-          </a:p>
-          <a:p>
-            <a:pPr lvl="2"/>
-            <a:r>
-              <a:rPr lang="en-GB"/>
-              <a:t>Third level</a:t>
-            </a:r>
-          </a:p>
-          <a:p>
-            <a:pPr lvl="3"/>
-            <a:r>
-              <a:rPr lang="en-GB"/>
-              <a:t>Fourth level</a:t>
-            </a:r>
-          </a:p>
-          <a:p>
-            <a:pPr lvl="4"/>
-            <a:r>
-              <a:rPr lang="en-GB"/>
-              <a:t>Fifth level</a:t>
-            </a:r>
-            <a:endParaRPr lang="en-US" dirty="0"/>
+            <a:endParaRPr lang="en-US"/>
           </a:p>
         </p:txBody>
       </p:sp>
@@ -1463,22 +1335,14 @@
             <p:ph type="dt" sz="half" idx="10"/>
           </p:nvPr>
         </p:nvSpPr>
-        <p:spPr>
-          <a:xfrm>
-            <a:off x="1472635" y="28060644"/>
-            <a:ext cx="4819531" cy="1611875"/>
-          </a:xfrm>
-          <a:prstGeom prst="rect">
-            <a:avLst/>
-          </a:prstGeom>
-        </p:spPr>
-        <p:txBody>
-          <a:bodyPr/>
-          <a:lstStyle/>
-          <a:p>
-            <a:fld id="{A18AD862-C623-2F4C-8F0F-0FC2EEA5CCAC}" type="datetimeFigureOut">
-              <a:rPr lang="en-US" smtClean="0"/>
-              <a:t>5/15/2026</a:t>
+        <p:spPr/>
+        <p:txBody>
+          <a:bodyPr/>
+          <a:lstStyle/>
+          <a:p>
+            <a:fld id="{5BCAD085-E8A6-8845-BD4E-CB4CCA059FC4}" type="datetimeFigureOut">
+              <a:rPr lang="en-US" smtClean="0"/>
+              <a:t>1/27/13</a:t>
             </a:fld>
             <a:endParaRPr lang="en-US"/>
           </a:p>
@@ -1494,15 +1358,7 @@
             <p:ph type="ftr" sz="quarter" idx="11"/>
           </p:nvPr>
         </p:nvSpPr>
-        <p:spPr>
-          <a:xfrm>
-            <a:off x="7095421" y="28060644"/>
-            <a:ext cx="7229297" cy="1611875"/>
-          </a:xfrm>
-          <a:prstGeom prst="rect">
-            <a:avLst/>
-          </a:prstGeom>
-        </p:spPr>
+        <p:spPr/>
         <p:txBody>
           <a:bodyPr/>
           <a:lstStyle/>
@@ -1521,20 +1377,12 @@
             <p:ph type="sldNum" sz="quarter" idx="12"/>
           </p:nvPr>
         </p:nvSpPr>
-        <p:spPr>
-          <a:xfrm>
-            <a:off x="15127972" y="28060644"/>
-            <a:ext cx="4819531" cy="1611875"/>
-          </a:xfrm>
-          <a:prstGeom prst="rect">
-            <a:avLst/>
-          </a:prstGeom>
-        </p:spPr>
-        <p:txBody>
-          <a:bodyPr/>
-          <a:lstStyle/>
-          <a:p>
-            <a:fld id="{CF2C3D6F-2254-F942-82E9-860973A72D47}" type="slidenum">
+        <p:spPr/>
+        <p:txBody>
+          <a:bodyPr/>
+          <a:lstStyle/>
+          <a:p>
+            <a:fld id="{C1FF6DA9-008F-8B48-92A6-B652298478BF}" type="slidenum">
               <a:rPr lang="en-US" smtClean="0"/>
               <a:t>‹#›</a:t>
             </a:fld>
@@ -1545,7 +1393,7 @@
     </p:spTree>
     <p:extLst>
       <p:ext uri="{BB962C8B-B14F-4D97-AF65-F5344CB8AC3E}">
-        <p14:creationId xmlns:p14="http://schemas.microsoft.com/office/powerpoint/2010/main" val="4105748889"/>
+        <p14:creationId xmlns:p14="http://schemas.microsoft.com/office/powerpoint/2010/main" val="2782244947"/>
       </p:ext>
     </p:extLst>
   </p:cSld>
@@ -1582,90 +1430,83 @@
             <p:ph type="title"/>
           </p:nvPr>
         </p:nvSpPr>
+        <p:spPr/>
+        <p:txBody>
+          <a:bodyPr/>
+          <a:lstStyle>
+            <a:lvl1pPr>
+              <a:defRPr/>
+            </a:lvl1pPr>
+          </a:lstStyle>
+          <a:p>
+            <a:r>
+              <a:rPr lang="en-US" smtClean="0"/>
+              <a:t>Click to edit Master title style</a:t>
+            </a:r>
+            <a:endParaRPr lang="en-US"/>
+          </a:p>
+        </p:txBody>
+      </p:sp>
+      <p:sp>
+        <p:nvSpPr>
+          <p:cNvPr id="3" name="Text Placeholder 2"/>
+          <p:cNvSpPr>
+            <a:spLocks noGrp="1"/>
+          </p:cNvSpPr>
+          <p:nvPr>
+            <p:ph type="body" idx="1"/>
+          </p:nvPr>
+        </p:nvSpPr>
         <p:spPr>
           <a:xfrm>
-            <a:off x="1475424" y="1611882"/>
-            <a:ext cx="18474869" cy="5851808"/>
+            <a:off x="457200" y="1535113"/>
+            <a:ext cx="4040188" cy="639762"/>
           </a:xfrm>
-          <a:prstGeom prst="rect">
-            <a:avLst/>
-          </a:prstGeom>
-        </p:spPr>
-        <p:txBody>
-          <a:bodyPr/>
-          <a:lstStyle/>
-          <a:p>
-            <a:r>
-              <a:rPr lang="en-GB"/>
-              <a:t>Click to edit Master title style</a:t>
-            </a:r>
-            <a:endParaRPr lang="en-US" dirty="0"/>
-          </a:p>
-        </p:txBody>
-      </p:sp>
-      <p:sp>
-        <p:nvSpPr>
-          <p:cNvPr id="3" name="Text Placeholder 2"/>
-          <p:cNvSpPr>
-            <a:spLocks noGrp="1"/>
-          </p:cNvSpPr>
-          <p:nvPr>
-            <p:ph type="body" idx="1"/>
-          </p:nvPr>
-        </p:nvSpPr>
-        <p:spPr>
-          <a:xfrm>
-            <a:off x="1475427" y="7421634"/>
-            <a:ext cx="9061721" cy="3637228"/>
-          </a:xfrm>
-          <a:prstGeom prst="rect">
-            <a:avLst/>
-          </a:prstGeom>
         </p:spPr>
         <p:txBody>
           <a:bodyPr anchor="b"/>
           <a:lstStyle>
             <a:lvl1pPr marL="0" indent="0">
               <a:buNone/>
-              <a:defRPr sz="5622" b="1"/>
+              <a:defRPr sz="2400" b="1"/>
             </a:lvl1pPr>
-            <a:lvl2pPr marL="1070991" indent="0">
-              <a:buNone/>
-              <a:defRPr sz="4685" b="1"/>
+            <a:lvl2pPr marL="457200" indent="0">
+              <a:buNone/>
+              <a:defRPr sz="2000" b="1"/>
             </a:lvl2pPr>
-            <a:lvl3pPr marL="2141982" indent="0">
-              <a:buNone/>
-              <a:defRPr sz="4217" b="1"/>
+            <a:lvl3pPr marL="914400" indent="0">
+              <a:buNone/>
+              <a:defRPr sz="1800" b="1"/>
             </a:lvl3pPr>
-            <a:lvl4pPr marL="3212973" indent="0">
-              <a:buNone/>
-              <a:defRPr sz="3748" b="1"/>
+            <a:lvl4pPr marL="1371600" indent="0">
+              <a:buNone/>
+              <a:defRPr sz="1600" b="1"/>
             </a:lvl4pPr>
-            <a:lvl5pPr marL="4283964" indent="0">
-              <a:buNone/>
-              <a:defRPr sz="3748" b="1"/>
+            <a:lvl5pPr marL="1828800" indent="0">
+              <a:buNone/>
+              <a:defRPr sz="1600" b="1"/>
             </a:lvl5pPr>
-            <a:lvl6pPr marL="5354955" indent="0">
-              <a:buNone/>
-              <a:defRPr sz="3748" b="1"/>
+            <a:lvl6pPr marL="2286000" indent="0">
+              <a:buNone/>
+              <a:defRPr sz="1600" b="1"/>
             </a:lvl6pPr>
-            <a:lvl7pPr marL="6425946" indent="0">
-              <a:buNone/>
-              <a:defRPr sz="3748" b="1"/>
+            <a:lvl7pPr marL="2743200" indent="0">
+              <a:buNone/>
+              <a:defRPr sz="1600" b="1"/>
             </a:lvl7pPr>
-            <a:lvl8pPr marL="7496937" indent="0">
-              <a:buNone/>
-              <a:defRPr sz="3748" b="1"/>
+            <a:lvl8pPr marL="3200400" indent="0">
+              <a:buNone/>
+              <a:defRPr sz="1600" b="1"/>
             </a:lvl8pPr>
-            <a:lvl9pPr marL="8567928" indent="0">
-              <a:buNone/>
-              <a:defRPr sz="3748" b="1"/>
+            <a:lvl9pPr marL="3657600" indent="0">
+              <a:buNone/>
+              <a:defRPr sz="1600" b="1"/>
             </a:lvl9pPr>
           </a:lstStyle>
           <a:p>
             <a:pPr lvl="0"/>
             <a:r>
-              <a:rPr lang="en-GB"/>
+              <a:rPr lang="en-US" smtClean="0"/>
               <a:t>Click to edit Master text styles</a:t>
             </a:r>
           </a:p>
@@ -1683,51 +1524,76 @@
         </p:nvSpPr>
         <p:spPr>
           <a:xfrm>
-            <a:off x="1475427" y="11058863"/>
-            <a:ext cx="9061721" cy="16265921"/>
+            <a:off x="457200" y="2174875"/>
+            <a:ext cx="4040188" cy="3951288"/>
           </a:xfrm>
-          <a:prstGeom prst="rect">
-            <a:avLst/>
-          </a:prstGeom>
         </p:spPr>
         <p:txBody>
           <a:bodyPr/>
-          <a:lstStyle/>
+          <a:lstStyle>
+            <a:lvl1pPr>
+              <a:defRPr sz="2400"/>
+            </a:lvl1pPr>
+            <a:lvl2pPr>
+              <a:defRPr sz="2000"/>
+            </a:lvl2pPr>
+            <a:lvl3pPr>
+              <a:defRPr sz="1800"/>
+            </a:lvl3pPr>
+            <a:lvl4pPr>
+              <a:defRPr sz="1600"/>
+            </a:lvl4pPr>
+            <a:lvl5pPr>
+              <a:defRPr sz="1600"/>
+            </a:lvl5pPr>
+            <a:lvl6pPr>
+              <a:defRPr sz="1600"/>
+            </a:lvl6pPr>
+            <a:lvl7pPr>
+              <a:defRPr sz="1600"/>
+            </a:lvl7pPr>
+            <a:lvl8pPr>
+              <a:defRPr sz="1600"/>
+            </a:lvl8pPr>
+            <a:lvl9pPr>
+              <a:defRPr sz="1600"/>
+            </a:lvl9pPr>
+          </a:lstStyle>
           <a:p>
             <a:pPr lvl="0"/>
             <a:r>
-              <a:rPr lang="en-GB"/>
+              <a:rPr lang="en-US" smtClean="0"/>
               <a:t>Click to edit Master text styles</a:t>
             </a:r>
           </a:p>
           <a:p>
             <a:pPr lvl="1"/>
             <a:r>
-              <a:rPr lang="en-GB"/>
+              <a:rPr lang="en-US" smtClean="0"/>
               <a:t>Second level</a:t>
             </a:r>
           </a:p>
           <a:p>
             <a:pPr lvl="2"/>
             <a:r>
-              <a:rPr lang="en-GB"/>
+              <a:rPr lang="en-US" smtClean="0"/>
               <a:t>Third level</a:t>
             </a:r>
           </a:p>
           <a:p>
             <a:pPr lvl="3"/>
             <a:r>
-              <a:rPr lang="en-GB"/>
+              <a:rPr lang="en-US" smtClean="0"/>
               <a:t>Fourth level</a:t>
             </a:r>
           </a:p>
           <a:p>
             <a:pPr lvl="4"/>
             <a:r>
-              <a:rPr lang="en-GB"/>
+              <a:rPr lang="en-US" smtClean="0"/>
               <a:t>Fifth level</a:t>
             </a:r>
-            <a:endParaRPr lang="en-US" dirty="0"/>
+            <a:endParaRPr lang="en-US"/>
           </a:p>
         </p:txBody>
       </p:sp>
@@ -1743,57 +1609,54 @@
         </p:nvSpPr>
         <p:spPr>
           <a:xfrm>
-            <a:off x="10843946" y="7421634"/>
-            <a:ext cx="9106349" cy="3637228"/>
+            <a:off x="4645025" y="1535113"/>
+            <a:ext cx="4041775" cy="639762"/>
           </a:xfrm>
-          <a:prstGeom prst="rect">
-            <a:avLst/>
-          </a:prstGeom>
         </p:spPr>
         <p:txBody>
           <a:bodyPr anchor="b"/>
           <a:lstStyle>
             <a:lvl1pPr marL="0" indent="0">
               <a:buNone/>
-              <a:defRPr sz="5622" b="1"/>
+              <a:defRPr sz="2400" b="1"/>
             </a:lvl1pPr>
-            <a:lvl2pPr marL="1070991" indent="0">
-              <a:buNone/>
-              <a:defRPr sz="4685" b="1"/>
+            <a:lvl2pPr marL="457200" indent="0">
+              <a:buNone/>
+              <a:defRPr sz="2000" b="1"/>
             </a:lvl2pPr>
-            <a:lvl3pPr marL="2141982" indent="0">
-              <a:buNone/>
-              <a:defRPr sz="4217" b="1"/>
+            <a:lvl3pPr marL="914400" indent="0">
+              <a:buNone/>
+              <a:defRPr sz="1800" b="1"/>
             </a:lvl3pPr>
-            <a:lvl4pPr marL="3212973" indent="0">
-              <a:buNone/>
-              <a:defRPr sz="3748" b="1"/>
+            <a:lvl4pPr marL="1371600" indent="0">
+              <a:buNone/>
+              <a:defRPr sz="1600" b="1"/>
             </a:lvl4pPr>
-            <a:lvl5pPr marL="4283964" indent="0">
-              <a:buNone/>
-              <a:defRPr sz="3748" b="1"/>
+            <a:lvl5pPr marL="1828800" indent="0">
+              <a:buNone/>
+              <a:defRPr sz="1600" b="1"/>
             </a:lvl5pPr>
-            <a:lvl6pPr marL="5354955" indent="0">
-              <a:buNone/>
-              <a:defRPr sz="3748" b="1"/>
+            <a:lvl6pPr marL="2286000" indent="0">
+              <a:buNone/>
+              <a:defRPr sz="1600" b="1"/>
             </a:lvl6pPr>
-            <a:lvl7pPr marL="6425946" indent="0">
-              <a:buNone/>
-              <a:defRPr sz="3748" b="1"/>
+            <a:lvl7pPr marL="2743200" indent="0">
+              <a:buNone/>
+              <a:defRPr sz="1600" b="1"/>
             </a:lvl7pPr>
-            <a:lvl8pPr marL="7496937" indent="0">
-              <a:buNone/>
-              <a:defRPr sz="3748" b="1"/>
+            <a:lvl8pPr marL="3200400" indent="0">
+              <a:buNone/>
+              <a:defRPr sz="1600" b="1"/>
             </a:lvl8pPr>
-            <a:lvl9pPr marL="8567928" indent="0">
-              <a:buNone/>
-              <a:defRPr sz="3748" b="1"/>
+            <a:lvl9pPr marL="3657600" indent="0">
+              <a:buNone/>
+              <a:defRPr sz="1600" b="1"/>
             </a:lvl9pPr>
           </a:lstStyle>
           <a:p>
             <a:pPr lvl="0"/>
             <a:r>
-              <a:rPr lang="en-GB"/>
+              <a:rPr lang="en-US" smtClean="0"/>
               <a:t>Click to edit Master text styles</a:t>
             </a:r>
           </a:p>
@@ -1811,51 +1674,76 @@
         </p:nvSpPr>
         <p:spPr>
           <a:xfrm>
-            <a:off x="10843946" y="11058863"/>
-            <a:ext cx="9106349" cy="16265921"/>
+            <a:off x="4645025" y="2174875"/>
+            <a:ext cx="4041775" cy="3951288"/>
           </a:xfrm>
-          <a:prstGeom prst="rect">
-            <a:avLst/>
-          </a:prstGeom>
         </p:spPr>
         <p:txBody>
           <a:bodyPr/>
-          <a:lstStyle/>
+          <a:lstStyle>
+            <a:lvl1pPr>
+              <a:defRPr sz="2400"/>
+            </a:lvl1pPr>
+            <a:lvl2pPr>
+              <a:defRPr sz="2000"/>
+            </a:lvl2pPr>
+            <a:lvl3pPr>
+              <a:defRPr sz="1800"/>
+            </a:lvl3pPr>
+            <a:lvl4pPr>
+              <a:defRPr sz="1600"/>
+            </a:lvl4pPr>
+            <a:lvl5pPr>
+              <a:defRPr sz="1600"/>
+            </a:lvl5pPr>
+            <a:lvl6pPr>
+              <a:defRPr sz="1600"/>
+            </a:lvl6pPr>
+            <a:lvl7pPr>
+              <a:defRPr sz="1600"/>
+            </a:lvl7pPr>
+            <a:lvl8pPr>
+              <a:defRPr sz="1600"/>
+            </a:lvl8pPr>
+            <a:lvl9pPr>
+              <a:defRPr sz="1600"/>
+            </a:lvl9pPr>
+          </a:lstStyle>
           <a:p>
             <a:pPr lvl="0"/>
             <a:r>
-              <a:rPr lang="en-GB"/>
+              <a:rPr lang="en-US" smtClean="0"/>
               <a:t>Click to edit Master text styles</a:t>
             </a:r>
           </a:p>
           <a:p>
             <a:pPr lvl="1"/>
             <a:r>
-              <a:rPr lang="en-GB"/>
+              <a:rPr lang="en-US" smtClean="0"/>
               <a:t>Second level</a:t>
             </a:r>
           </a:p>
           <a:p>
             <a:pPr lvl="2"/>
             <a:r>
-              <a:rPr lang="en-GB"/>
+              <a:rPr lang="en-US" smtClean="0"/>
               <a:t>Third level</a:t>
             </a:r>
           </a:p>
           <a:p>
             <a:pPr lvl="3"/>
             <a:r>
-              <a:rPr lang="en-GB"/>
+              <a:rPr lang="en-US" smtClean="0"/>
               <a:t>Fourth level</a:t>
             </a:r>
           </a:p>
           <a:p>
             <a:pPr lvl="4"/>
             <a:r>
-              <a:rPr lang="en-GB"/>
+              <a:rPr lang="en-US" smtClean="0"/>
               <a:t>Fifth level</a:t>
             </a:r>
-            <a:endParaRPr lang="en-US" dirty="0"/>
+            <a:endParaRPr lang="en-US"/>
           </a:p>
         </p:txBody>
       </p:sp>
@@ -1869,22 +1757,14 @@
             <p:ph type="dt" sz="half" idx="10"/>
           </p:nvPr>
         </p:nvSpPr>
-        <p:spPr>
-          <a:xfrm>
-            <a:off x="1472635" y="28060644"/>
-            <a:ext cx="4819531" cy="1611875"/>
-          </a:xfrm>
-          <a:prstGeom prst="rect">
-            <a:avLst/>
-          </a:prstGeom>
-        </p:spPr>
-        <p:txBody>
-          <a:bodyPr/>
-          <a:lstStyle/>
-          <a:p>
-            <a:fld id="{A18AD862-C623-2F4C-8F0F-0FC2EEA5CCAC}" type="datetimeFigureOut">
-              <a:rPr lang="en-US" smtClean="0"/>
-              <a:t>5/15/2026</a:t>
+        <p:spPr/>
+        <p:txBody>
+          <a:bodyPr/>
+          <a:lstStyle/>
+          <a:p>
+            <a:fld id="{5BCAD085-E8A6-8845-BD4E-CB4CCA059FC4}" type="datetimeFigureOut">
+              <a:rPr lang="en-US" smtClean="0"/>
+              <a:t>1/27/13</a:t>
             </a:fld>
             <a:endParaRPr lang="en-US"/>
           </a:p>
@@ -1900,15 +1780,7 @@
             <p:ph type="ftr" sz="quarter" idx="11"/>
           </p:nvPr>
         </p:nvSpPr>
-        <p:spPr>
-          <a:xfrm>
-            <a:off x="7095421" y="28060644"/>
-            <a:ext cx="7229297" cy="1611875"/>
-          </a:xfrm>
-          <a:prstGeom prst="rect">
-            <a:avLst/>
-          </a:prstGeom>
-        </p:spPr>
+        <p:spPr/>
         <p:txBody>
           <a:bodyPr/>
           <a:lstStyle/>
@@ -1927,20 +1799,12 @@
             <p:ph type="sldNum" sz="quarter" idx="12"/>
           </p:nvPr>
         </p:nvSpPr>
-        <p:spPr>
-          <a:xfrm>
-            <a:off x="15127972" y="28060644"/>
-            <a:ext cx="4819531" cy="1611875"/>
-          </a:xfrm>
-          <a:prstGeom prst="rect">
-            <a:avLst/>
-          </a:prstGeom>
-        </p:spPr>
-        <p:txBody>
-          <a:bodyPr/>
-          <a:lstStyle/>
-          <a:p>
-            <a:fld id="{CF2C3D6F-2254-F942-82E9-860973A72D47}" type="slidenum">
+        <p:spPr/>
+        <p:txBody>
+          <a:bodyPr/>
+          <a:lstStyle/>
+          <a:p>
+            <a:fld id="{C1FF6DA9-008F-8B48-92A6-B652298478BF}" type="slidenum">
               <a:rPr lang="en-US" smtClean="0"/>
               <a:t>‹#›</a:t>
             </a:fld>
@@ -1951,7 +1815,7 @@
     </p:spTree>
     <p:extLst>
       <p:ext uri="{BB962C8B-B14F-4D97-AF65-F5344CB8AC3E}">
-        <p14:creationId xmlns:p14="http://schemas.microsoft.com/office/powerpoint/2010/main" val="1792405854"/>
+        <p14:creationId xmlns:p14="http://schemas.microsoft.com/office/powerpoint/2010/main" val="990158736"/>
       </p:ext>
     </p:extLst>
   </p:cSld>
@@ -1988,24 +1852,16 @@
             <p:ph type="title"/>
           </p:nvPr>
         </p:nvSpPr>
-        <p:spPr>
-          <a:xfrm>
-            <a:off x="1472635" y="1611882"/>
-            <a:ext cx="18474869" cy="5851808"/>
-          </a:xfrm>
-          <a:prstGeom prst="rect">
-            <a:avLst/>
-          </a:prstGeom>
-        </p:spPr>
-        <p:txBody>
-          <a:bodyPr/>
-          <a:lstStyle/>
-          <a:p>
-            <a:r>
-              <a:rPr lang="en-GB"/>
+        <p:spPr/>
+        <p:txBody>
+          <a:bodyPr/>
+          <a:lstStyle/>
+          <a:p>
+            <a:r>
+              <a:rPr lang="en-US" smtClean="0"/>
               <a:t>Click to edit Master title style</a:t>
             </a:r>
-            <a:endParaRPr lang="en-US" dirty="0"/>
+            <a:endParaRPr lang="en-US"/>
           </a:p>
         </p:txBody>
       </p:sp>
@@ -2019,22 +1875,14 @@
             <p:ph type="dt" sz="half" idx="10"/>
           </p:nvPr>
         </p:nvSpPr>
-        <p:spPr>
-          <a:xfrm>
-            <a:off x="1472635" y="28060644"/>
-            <a:ext cx="4819531" cy="1611875"/>
-          </a:xfrm>
-          <a:prstGeom prst="rect">
-            <a:avLst/>
-          </a:prstGeom>
-        </p:spPr>
-        <p:txBody>
-          <a:bodyPr/>
-          <a:lstStyle/>
-          <a:p>
-            <a:fld id="{A18AD862-C623-2F4C-8F0F-0FC2EEA5CCAC}" type="datetimeFigureOut">
-              <a:rPr lang="en-US" smtClean="0"/>
-              <a:t>5/15/2026</a:t>
+        <p:spPr/>
+        <p:txBody>
+          <a:bodyPr/>
+          <a:lstStyle/>
+          <a:p>
+            <a:fld id="{5BCAD085-E8A6-8845-BD4E-CB4CCA059FC4}" type="datetimeFigureOut">
+              <a:rPr lang="en-US" smtClean="0"/>
+              <a:t>1/27/13</a:t>
             </a:fld>
             <a:endParaRPr lang="en-US"/>
           </a:p>
@@ -2050,15 +1898,7 @@
             <p:ph type="ftr" sz="quarter" idx="11"/>
           </p:nvPr>
         </p:nvSpPr>
-        <p:spPr>
-          <a:xfrm>
-            <a:off x="7095421" y="28060644"/>
-            <a:ext cx="7229297" cy="1611875"/>
-          </a:xfrm>
-          <a:prstGeom prst="rect">
-            <a:avLst/>
-          </a:prstGeom>
-        </p:spPr>
+        <p:spPr/>
         <p:txBody>
           <a:bodyPr/>
           <a:lstStyle/>
@@ -2077,20 +1917,12 @@
             <p:ph type="sldNum" sz="quarter" idx="12"/>
           </p:nvPr>
         </p:nvSpPr>
-        <p:spPr>
-          <a:xfrm>
-            <a:off x="15127972" y="28060644"/>
-            <a:ext cx="4819531" cy="1611875"/>
-          </a:xfrm>
-          <a:prstGeom prst="rect">
-            <a:avLst/>
-          </a:prstGeom>
-        </p:spPr>
-        <p:txBody>
-          <a:bodyPr/>
-          <a:lstStyle/>
-          <a:p>
-            <a:fld id="{CF2C3D6F-2254-F942-82E9-860973A72D47}" type="slidenum">
+        <p:spPr/>
+        <p:txBody>
+          <a:bodyPr/>
+          <a:lstStyle/>
+          <a:p>
+            <a:fld id="{C1FF6DA9-008F-8B48-92A6-B652298478BF}" type="slidenum">
               <a:rPr lang="en-US" smtClean="0"/>
               <a:t>‹#›</a:t>
             </a:fld>
@@ -2101,7 +1933,7 @@
     </p:spTree>
     <p:extLst>
       <p:ext uri="{BB962C8B-B14F-4D97-AF65-F5344CB8AC3E}">
-        <p14:creationId xmlns:p14="http://schemas.microsoft.com/office/powerpoint/2010/main" val="2541240830"/>
+        <p14:creationId xmlns:p14="http://schemas.microsoft.com/office/powerpoint/2010/main" val="727027711"/>
       </p:ext>
     </p:extLst>
   </p:cSld>
@@ -2138,22 +1970,14 @@
             <p:ph type="dt" sz="half" idx="10"/>
           </p:nvPr>
         </p:nvSpPr>
-        <p:spPr>
-          <a:xfrm>
-            <a:off x="1472635" y="28060644"/>
-            <a:ext cx="4819531" cy="1611875"/>
-          </a:xfrm>
-          <a:prstGeom prst="rect">
-            <a:avLst/>
-          </a:prstGeom>
-        </p:spPr>
-        <p:txBody>
-          <a:bodyPr/>
-          <a:lstStyle/>
-          <a:p>
-            <a:fld id="{A18AD862-C623-2F4C-8F0F-0FC2EEA5CCAC}" type="datetimeFigureOut">
-              <a:rPr lang="en-US" smtClean="0"/>
-              <a:t>5/15/2026</a:t>
+        <p:spPr/>
+        <p:txBody>
+          <a:bodyPr/>
+          <a:lstStyle/>
+          <a:p>
+            <a:fld id="{5BCAD085-E8A6-8845-BD4E-CB4CCA059FC4}" type="datetimeFigureOut">
+              <a:rPr lang="en-US" smtClean="0"/>
+              <a:t>1/27/13</a:t>
             </a:fld>
             <a:endParaRPr lang="en-US"/>
           </a:p>
@@ -2169,15 +1993,7 @@
             <p:ph type="ftr" sz="quarter" idx="11"/>
           </p:nvPr>
         </p:nvSpPr>
-        <p:spPr>
-          <a:xfrm>
-            <a:off x="7095421" y="28060644"/>
-            <a:ext cx="7229297" cy="1611875"/>
-          </a:xfrm>
-          <a:prstGeom prst="rect">
-            <a:avLst/>
-          </a:prstGeom>
-        </p:spPr>
+        <p:spPr/>
         <p:txBody>
           <a:bodyPr/>
           <a:lstStyle/>
@@ -2196,20 +2012,12 @@
             <p:ph type="sldNum" sz="quarter" idx="12"/>
           </p:nvPr>
         </p:nvSpPr>
-        <p:spPr>
-          <a:xfrm>
-            <a:off x="15127972" y="28060644"/>
-            <a:ext cx="4819531" cy="1611875"/>
-          </a:xfrm>
-          <a:prstGeom prst="rect">
-            <a:avLst/>
-          </a:prstGeom>
-        </p:spPr>
-        <p:txBody>
-          <a:bodyPr/>
-          <a:lstStyle/>
-          <a:p>
-            <a:fld id="{CF2C3D6F-2254-F942-82E9-860973A72D47}" type="slidenum">
+        <p:spPr/>
+        <p:txBody>
+          <a:bodyPr/>
+          <a:lstStyle/>
+          <a:p>
+            <a:fld id="{C1FF6DA9-008F-8B48-92A6-B652298478BF}" type="slidenum">
               <a:rPr lang="en-US" smtClean="0"/>
               <a:t>‹#›</a:t>
             </a:fld>
@@ -2220,7 +2028,7 @@
     </p:spTree>
     <p:extLst>
       <p:ext uri="{BB962C8B-B14F-4D97-AF65-F5344CB8AC3E}">
-        <p14:creationId xmlns:p14="http://schemas.microsoft.com/office/powerpoint/2010/main" val="206202351"/>
+        <p14:creationId xmlns:p14="http://schemas.microsoft.com/office/powerpoint/2010/main" val="1212999818"/>
       </p:ext>
     </p:extLst>
   </p:cSld>
@@ -2259,26 +2067,23 @@
         </p:nvSpPr>
         <p:spPr>
           <a:xfrm>
-            <a:off x="1475424" y="2018348"/>
-            <a:ext cx="6908552" cy="7064216"/>
+            <a:off x="457200" y="273050"/>
+            <a:ext cx="3008313" cy="1162050"/>
           </a:xfrm>
-          <a:prstGeom prst="rect">
-            <a:avLst/>
-          </a:prstGeom>
         </p:spPr>
         <p:txBody>
           <a:bodyPr anchor="b"/>
           <a:lstStyle>
-            <a:lvl1pPr>
-              <a:defRPr sz="7496"/>
+            <a:lvl1pPr algn="l">
+              <a:defRPr sz="2000" b="1"/>
             </a:lvl1pPr>
           </a:lstStyle>
           <a:p>
             <a:r>
-              <a:rPr lang="en-GB"/>
+              <a:rPr lang="en-US" smtClean="0"/>
               <a:t>Click to edit Master title style</a:t>
             </a:r>
-            <a:endParaRPr lang="en-US" dirty="0"/>
+            <a:endParaRPr lang="en-US"/>
           </a:p>
         </p:txBody>
       </p:sp>
@@ -2294,79 +2099,76 @@
         </p:nvSpPr>
         <p:spPr>
           <a:xfrm>
-            <a:off x="9106349" y="4359077"/>
-            <a:ext cx="10843945" cy="21515024"/>
+            <a:off x="3575050" y="273050"/>
+            <a:ext cx="5111750" cy="5853113"/>
           </a:xfrm>
-          <a:prstGeom prst="rect">
-            <a:avLst/>
-          </a:prstGeom>
         </p:spPr>
         <p:txBody>
           <a:bodyPr/>
           <a:lstStyle>
             <a:lvl1pPr>
-              <a:defRPr sz="7496"/>
+              <a:defRPr sz="3200"/>
             </a:lvl1pPr>
             <a:lvl2pPr>
-              <a:defRPr sz="6559"/>
+              <a:defRPr sz="2800"/>
             </a:lvl2pPr>
             <a:lvl3pPr>
-              <a:defRPr sz="5622"/>
+              <a:defRPr sz="2400"/>
             </a:lvl3pPr>
             <a:lvl4pPr>
-              <a:defRPr sz="4685"/>
+              <a:defRPr sz="2000"/>
             </a:lvl4pPr>
             <a:lvl5pPr>
-              <a:defRPr sz="4685"/>
+              <a:defRPr sz="2000"/>
             </a:lvl5pPr>
             <a:lvl6pPr>
-              <a:defRPr sz="4685"/>
+              <a:defRPr sz="2000"/>
             </a:lvl6pPr>
             <a:lvl7pPr>
-              <a:defRPr sz="4685"/>
+              <a:defRPr sz="2000"/>
             </a:lvl7pPr>
             <a:lvl8pPr>
-              <a:defRPr sz="4685"/>
+              <a:defRPr sz="2000"/>
             </a:lvl8pPr>
             <a:lvl9pPr>
-              <a:defRPr sz="4685"/>
+              <a:defRPr sz="2000"/>
             </a:lvl9pPr>
           </a:lstStyle>
           <a:p>
             <a:pPr lvl="0"/>
             <a:r>
-              <a:rPr lang="en-GB"/>
+              <a:rPr lang="en-US" smtClean="0"/>
               <a:t>Click to edit Master text styles</a:t>
             </a:r>
           </a:p>
           <a:p>
             <a:pPr lvl="1"/>
             <a:r>
-              <a:rPr lang="en-GB"/>
+              <a:rPr lang="en-US" smtClean="0"/>
               <a:t>Second level</a:t>
             </a:r>
           </a:p>
           <a:p>
             <a:pPr lvl="2"/>
             <a:r>
-              <a:rPr lang="en-GB"/>
+              <a:rPr lang="en-US" smtClean="0"/>
               <a:t>Third level</a:t>
             </a:r>
           </a:p>
           <a:p>
             <a:pPr lvl="3"/>
             <a:r>
-              <a:rPr lang="en-GB"/>
+              <a:rPr lang="en-US" smtClean="0"/>
               <a:t>Fourth level</a:t>
             </a:r>
           </a:p>
           <a:p>
             <a:pPr lvl="4"/>
             <a:r>
-              <a:rPr lang="en-GB"/>
+              <a:rPr lang="en-US" smtClean="0"/>
               <a:t>Fifth level</a:t>
             </a:r>
-            <a:endParaRPr lang="en-US" dirty="0"/>
+            <a:endParaRPr lang="en-US"/>
           </a:p>
         </p:txBody>
       </p:sp>
@@ -2382,57 +2184,54 @@
         </p:nvSpPr>
         <p:spPr>
           <a:xfrm>
-            <a:off x="1475424" y="9082564"/>
-            <a:ext cx="6908552" cy="16826573"/>
+            <a:off x="457200" y="1435100"/>
+            <a:ext cx="3008313" cy="4691063"/>
           </a:xfrm>
-          <a:prstGeom prst="rect">
-            <a:avLst/>
-          </a:prstGeom>
         </p:spPr>
         <p:txBody>
           <a:bodyPr/>
           <a:lstStyle>
             <a:lvl1pPr marL="0" indent="0">
               <a:buNone/>
-              <a:defRPr sz="3748"/>
+              <a:defRPr sz="1400"/>
             </a:lvl1pPr>
-            <a:lvl2pPr marL="1070991" indent="0">
-              <a:buNone/>
-              <a:defRPr sz="3280"/>
+            <a:lvl2pPr marL="457200" indent="0">
+              <a:buNone/>
+              <a:defRPr sz="1200"/>
             </a:lvl2pPr>
-            <a:lvl3pPr marL="2141982" indent="0">
-              <a:buNone/>
-              <a:defRPr sz="2811"/>
+            <a:lvl3pPr marL="914400" indent="0">
+              <a:buNone/>
+              <a:defRPr sz="1000"/>
             </a:lvl3pPr>
-            <a:lvl4pPr marL="3212973" indent="0">
-              <a:buNone/>
-              <a:defRPr sz="2343"/>
+            <a:lvl4pPr marL="1371600" indent="0">
+              <a:buNone/>
+              <a:defRPr sz="900"/>
             </a:lvl4pPr>
-            <a:lvl5pPr marL="4283964" indent="0">
-              <a:buNone/>
-              <a:defRPr sz="2343"/>
+            <a:lvl5pPr marL="1828800" indent="0">
+              <a:buNone/>
+              <a:defRPr sz="900"/>
             </a:lvl5pPr>
-            <a:lvl6pPr marL="5354955" indent="0">
-              <a:buNone/>
-              <a:defRPr sz="2343"/>
+            <a:lvl6pPr marL="2286000" indent="0">
+              <a:buNone/>
+              <a:defRPr sz="900"/>
             </a:lvl6pPr>
-            <a:lvl7pPr marL="6425946" indent="0">
-              <a:buNone/>
-              <a:defRPr sz="2343"/>
+            <a:lvl7pPr marL="2743200" indent="0">
+              <a:buNone/>
+              <a:defRPr sz="900"/>
             </a:lvl7pPr>
-            <a:lvl8pPr marL="7496937" indent="0">
-              <a:buNone/>
-              <a:defRPr sz="2343"/>
+            <a:lvl8pPr marL="3200400" indent="0">
+              <a:buNone/>
+              <a:defRPr sz="900"/>
             </a:lvl8pPr>
-            <a:lvl9pPr marL="8567928" indent="0">
-              <a:buNone/>
-              <a:defRPr sz="2343"/>
+            <a:lvl9pPr marL="3657600" indent="0">
+              <a:buNone/>
+              <a:defRPr sz="900"/>
             </a:lvl9pPr>
           </a:lstStyle>
           <a:p>
             <a:pPr lvl="0"/>
             <a:r>
-              <a:rPr lang="en-GB"/>
+              <a:rPr lang="en-US" smtClean="0"/>
               <a:t>Click to edit Master text styles</a:t>
             </a:r>
           </a:p>
@@ -2448,22 +2247,14 @@
             <p:ph type="dt" sz="half" idx="10"/>
           </p:nvPr>
         </p:nvSpPr>
-        <p:spPr>
-          <a:xfrm>
-            <a:off x="1472635" y="28060644"/>
-            <a:ext cx="4819531" cy="1611875"/>
-          </a:xfrm>
-          <a:prstGeom prst="rect">
-            <a:avLst/>
-          </a:prstGeom>
-        </p:spPr>
-        <p:txBody>
-          <a:bodyPr/>
-          <a:lstStyle/>
-          <a:p>
-            <a:fld id="{A18AD862-C623-2F4C-8F0F-0FC2EEA5CCAC}" type="datetimeFigureOut">
-              <a:rPr lang="en-US" smtClean="0"/>
-              <a:t>5/15/2026</a:t>
+        <p:spPr/>
+        <p:txBody>
+          <a:bodyPr/>
+          <a:lstStyle/>
+          <a:p>
+            <a:fld id="{5BCAD085-E8A6-8845-BD4E-CB4CCA059FC4}" type="datetimeFigureOut">
+              <a:rPr lang="en-US" smtClean="0"/>
+              <a:t>1/27/13</a:t>
             </a:fld>
             <a:endParaRPr lang="en-US"/>
           </a:p>
@@ -2479,15 +2270,7 @@
             <p:ph type="ftr" sz="quarter" idx="11"/>
           </p:nvPr>
         </p:nvSpPr>
-        <p:spPr>
-          <a:xfrm>
-            <a:off x="7095421" y="28060644"/>
-            <a:ext cx="7229297" cy="1611875"/>
-          </a:xfrm>
-          <a:prstGeom prst="rect">
-            <a:avLst/>
-          </a:prstGeom>
-        </p:spPr>
+        <p:spPr/>
         <p:txBody>
           <a:bodyPr/>
           <a:lstStyle/>
@@ -2506,20 +2289,12 @@
             <p:ph type="sldNum" sz="quarter" idx="12"/>
           </p:nvPr>
         </p:nvSpPr>
-        <p:spPr>
-          <a:xfrm>
-            <a:off x="15127972" y="28060644"/>
-            <a:ext cx="4819531" cy="1611875"/>
-          </a:xfrm>
-          <a:prstGeom prst="rect">
-            <a:avLst/>
-          </a:prstGeom>
-        </p:spPr>
-        <p:txBody>
-          <a:bodyPr/>
-          <a:lstStyle/>
-          <a:p>
-            <a:fld id="{CF2C3D6F-2254-F942-82E9-860973A72D47}" type="slidenum">
+        <p:spPr/>
+        <p:txBody>
+          <a:bodyPr/>
+          <a:lstStyle/>
+          <a:p>
+            <a:fld id="{C1FF6DA9-008F-8B48-92A6-B652298478BF}" type="slidenum">
               <a:rPr lang="en-US" smtClean="0"/>
               <a:t>‹#›</a:t>
             </a:fld>
@@ -2530,7 +2305,7 @@
     </p:spTree>
     <p:extLst>
       <p:ext uri="{BB962C8B-B14F-4D97-AF65-F5344CB8AC3E}">
-        <p14:creationId xmlns:p14="http://schemas.microsoft.com/office/powerpoint/2010/main" val="913074817"/>
+        <p14:creationId xmlns:p14="http://schemas.microsoft.com/office/powerpoint/2010/main" val="1840726560"/>
       </p:ext>
     </p:extLst>
   </p:cSld>
@@ -2569,26 +2344,23 @@
         </p:nvSpPr>
         <p:spPr>
           <a:xfrm>
-            <a:off x="1475424" y="2018348"/>
-            <a:ext cx="6908552" cy="7064216"/>
+            <a:off x="1792288" y="4800600"/>
+            <a:ext cx="5486400" cy="566738"/>
           </a:xfrm>
-          <a:prstGeom prst="rect">
-            <a:avLst/>
-          </a:prstGeom>
         </p:spPr>
         <p:txBody>
           <a:bodyPr anchor="b"/>
           <a:lstStyle>
-            <a:lvl1pPr>
-              <a:defRPr sz="7496"/>
+            <a:lvl1pPr algn="l">
+              <a:defRPr sz="2000" b="1"/>
             </a:lvl1pPr>
           </a:lstStyle>
           <a:p>
             <a:r>
-              <a:rPr lang="en-GB"/>
+              <a:rPr lang="en-US" smtClean="0"/>
               <a:t>Click to edit Master title style</a:t>
             </a:r>
-            <a:endParaRPr lang="en-US" dirty="0"/>
+            <a:endParaRPr lang="en-US"/>
           </a:p>
         </p:txBody>
       </p:sp>
@@ -2596,7 +2368,7 @@
         <p:nvSpPr>
           <p:cNvPr id="3" name="Picture Placeholder 2"/>
           <p:cNvSpPr>
-            <a:spLocks noGrp="1" noChangeAspect="1"/>
+            <a:spLocks noGrp="1"/>
           </p:cNvSpPr>
           <p:nvPr>
             <p:ph type="pic" idx="1"/>
@@ -2604,59 +2376,52 @@
         </p:nvSpPr>
         <p:spPr>
           <a:xfrm>
-            <a:off x="9106349" y="4359077"/>
-            <a:ext cx="10843945" cy="21515024"/>
+            <a:off x="1792288" y="612775"/>
+            <a:ext cx="5486400" cy="4114800"/>
           </a:xfrm>
-          <a:prstGeom prst="rect">
-            <a:avLst/>
-          </a:prstGeom>
         </p:spPr>
         <p:txBody>
-          <a:bodyPr anchor="t"/>
+          <a:bodyPr/>
           <a:lstStyle>
             <a:lvl1pPr marL="0" indent="0">
               <a:buNone/>
-              <a:defRPr sz="7496"/>
+              <a:defRPr sz="3200"/>
             </a:lvl1pPr>
-            <a:lvl2pPr marL="1070991" indent="0">
-              <a:buNone/>
-              <a:defRPr sz="6559"/>
+            <a:lvl2pPr marL="457200" indent="0">
+              <a:buNone/>
+              <a:defRPr sz="2800"/>
             </a:lvl2pPr>
-            <a:lvl3pPr marL="2141982" indent="0">
-              <a:buNone/>
-              <a:defRPr sz="5622"/>
+            <a:lvl3pPr marL="914400" indent="0">
+              <a:buNone/>
+              <a:defRPr sz="2400"/>
             </a:lvl3pPr>
-            <a:lvl4pPr marL="3212973" indent="0">
-              <a:buNone/>
-              <a:defRPr sz="4685"/>
+            <a:lvl4pPr marL="1371600" indent="0">
+              <a:buNone/>
+              <a:defRPr sz="2000"/>
             </a:lvl4pPr>
-            <a:lvl5pPr marL="4283964" indent="0">
-              <a:buNone/>
-              <a:defRPr sz="4685"/>
+            <a:lvl5pPr marL="1828800" indent="0">
+              <a:buNone/>
+              <a:defRPr sz="2000"/>
             </a:lvl5pPr>
-            <a:lvl6pPr marL="5354955" indent="0">
-              <a:buNone/>
-              <a:defRPr sz="4685"/>
+            <a:lvl6pPr marL="2286000" indent="0">
+              <a:buNone/>
+              <a:defRPr sz="2000"/>
             </a:lvl6pPr>
-            <a:lvl7pPr marL="6425946" indent="0">
-              <a:buNone/>
-              <a:defRPr sz="4685"/>
+            <a:lvl7pPr marL="2743200" indent="0">
+              <a:buNone/>
+              <a:defRPr sz="2000"/>
             </a:lvl7pPr>
-            <a:lvl8pPr marL="7496937" indent="0">
-              <a:buNone/>
-              <a:defRPr sz="4685"/>
+            <a:lvl8pPr marL="3200400" indent="0">
+              <a:buNone/>
+              <a:defRPr sz="2000"/>
             </a:lvl8pPr>
-            <a:lvl9pPr marL="8567928" indent="0">
-              <a:buNone/>
-              <a:defRPr sz="4685"/>
+            <a:lvl9pPr marL="3657600" indent="0">
+              <a:buNone/>
+              <a:defRPr sz="2000"/>
             </a:lvl9pPr>
           </a:lstStyle>
           <a:p>
-            <a:r>
-              <a:rPr lang="en-GB"/>
-              <a:t>Click icon to add picture</a:t>
-            </a:r>
-            <a:endParaRPr lang="en-US" dirty="0"/>
+            <a:endParaRPr lang="en-US"/>
           </a:p>
         </p:txBody>
       </p:sp>
@@ -2672,57 +2437,54 @@
         </p:nvSpPr>
         <p:spPr>
           <a:xfrm>
-            <a:off x="1475424" y="9082564"/>
-            <a:ext cx="6908552" cy="16826573"/>
+            <a:off x="1792288" y="5367338"/>
+            <a:ext cx="5486400" cy="804862"/>
           </a:xfrm>
-          <a:prstGeom prst="rect">
-            <a:avLst/>
-          </a:prstGeom>
         </p:spPr>
         <p:txBody>
           <a:bodyPr/>
           <a:lstStyle>
             <a:lvl1pPr marL="0" indent="0">
               <a:buNone/>
-              <a:defRPr sz="3748"/>
+              <a:defRPr sz="1400"/>
             </a:lvl1pPr>
-            <a:lvl2pPr marL="1070991" indent="0">
-              <a:buNone/>
-              <a:defRPr sz="3280"/>
+            <a:lvl2pPr marL="457200" indent="0">
+              <a:buNone/>
+              <a:defRPr sz="1200"/>
             </a:lvl2pPr>
-            <a:lvl3pPr marL="2141982" indent="0">
-              <a:buNone/>
-              <a:defRPr sz="2811"/>
+            <a:lvl3pPr marL="914400" indent="0">
+              <a:buNone/>
+              <a:defRPr sz="1000"/>
             </a:lvl3pPr>
-            <a:lvl4pPr marL="3212973" indent="0">
-              <a:buNone/>
-              <a:defRPr sz="2343"/>
+            <a:lvl4pPr marL="1371600" indent="0">
+              <a:buNone/>
+              <a:defRPr sz="900"/>
             </a:lvl4pPr>
-            <a:lvl5pPr marL="4283964" indent="0">
-              <a:buNone/>
-              <a:defRPr sz="2343"/>
+            <a:lvl5pPr marL="1828800" indent="0">
+              <a:buNone/>
+              <a:defRPr sz="900"/>
             </a:lvl5pPr>
-            <a:lvl6pPr marL="5354955" indent="0">
-              <a:buNone/>
-              <a:defRPr sz="2343"/>
+            <a:lvl6pPr marL="2286000" indent="0">
+              <a:buNone/>
+              <a:defRPr sz="900"/>
             </a:lvl6pPr>
-            <a:lvl7pPr marL="6425946" indent="0">
-              <a:buNone/>
-              <a:defRPr sz="2343"/>
+            <a:lvl7pPr marL="2743200" indent="0">
+              <a:buNone/>
+              <a:defRPr sz="900"/>
             </a:lvl7pPr>
-            <a:lvl8pPr marL="7496937" indent="0">
-              <a:buNone/>
-              <a:defRPr sz="2343"/>
+            <a:lvl8pPr marL="3200400" indent="0">
+              <a:buNone/>
+              <a:defRPr sz="900"/>
             </a:lvl8pPr>
-            <a:lvl9pPr marL="8567928" indent="0">
-              <a:buNone/>
-              <a:defRPr sz="2343"/>
+            <a:lvl9pPr marL="3657600" indent="0">
+              <a:buNone/>
+              <a:defRPr sz="900"/>
             </a:lvl9pPr>
           </a:lstStyle>
           <a:p>
             <a:pPr lvl="0"/>
             <a:r>
-              <a:rPr lang="en-GB"/>
+              <a:rPr lang="en-US" smtClean="0"/>
               <a:t>Click to edit Master text styles</a:t>
             </a:r>
           </a:p>
@@ -2738,22 +2500,14 @@
             <p:ph type="dt" sz="half" idx="10"/>
           </p:nvPr>
         </p:nvSpPr>
-        <p:spPr>
-          <a:xfrm>
-            <a:off x="1472635" y="28060644"/>
-            <a:ext cx="4819531" cy="1611875"/>
-          </a:xfrm>
-          <a:prstGeom prst="rect">
-            <a:avLst/>
-          </a:prstGeom>
-        </p:spPr>
-        <p:txBody>
-          <a:bodyPr/>
-          <a:lstStyle/>
-          <a:p>
-            <a:fld id="{A18AD862-C623-2F4C-8F0F-0FC2EEA5CCAC}" type="datetimeFigureOut">
-              <a:rPr lang="en-US" smtClean="0"/>
-              <a:t>5/15/2026</a:t>
+        <p:spPr/>
+        <p:txBody>
+          <a:bodyPr/>
+          <a:lstStyle/>
+          <a:p>
+            <a:fld id="{5BCAD085-E8A6-8845-BD4E-CB4CCA059FC4}" type="datetimeFigureOut">
+              <a:rPr lang="en-US" smtClean="0"/>
+              <a:t>1/27/13</a:t>
             </a:fld>
             <a:endParaRPr lang="en-US"/>
           </a:p>
@@ -2769,15 +2523,7 @@
             <p:ph type="ftr" sz="quarter" idx="11"/>
           </p:nvPr>
         </p:nvSpPr>
-        <p:spPr>
-          <a:xfrm>
-            <a:off x="7095421" y="28060644"/>
-            <a:ext cx="7229297" cy="1611875"/>
-          </a:xfrm>
-          <a:prstGeom prst="rect">
-            <a:avLst/>
-          </a:prstGeom>
-        </p:spPr>
+        <p:spPr/>
         <p:txBody>
           <a:bodyPr/>
           <a:lstStyle/>
@@ -2796,20 +2542,12 @@
             <p:ph type="sldNum" sz="quarter" idx="12"/>
           </p:nvPr>
         </p:nvSpPr>
-        <p:spPr>
-          <a:xfrm>
-            <a:off x="15127972" y="28060644"/>
-            <a:ext cx="4819531" cy="1611875"/>
-          </a:xfrm>
-          <a:prstGeom prst="rect">
-            <a:avLst/>
-          </a:prstGeom>
-        </p:spPr>
-        <p:txBody>
-          <a:bodyPr/>
-          <a:lstStyle/>
-          <a:p>
-            <a:fld id="{CF2C3D6F-2254-F942-82E9-860973A72D47}" type="slidenum">
+        <p:spPr/>
+        <p:txBody>
+          <a:bodyPr/>
+          <a:lstStyle/>
+          <a:p>
+            <a:fld id="{C1FF6DA9-008F-8B48-92A6-B652298478BF}" type="slidenum">
               <a:rPr lang="en-US" smtClean="0"/>
               <a:t>‹#›</a:t>
             </a:fld>
@@ -2820,7 +2558,7 @@
     </p:spTree>
     <p:extLst>
       <p:ext uri="{BB962C8B-B14F-4D97-AF65-F5344CB8AC3E}">
-        <p14:creationId xmlns:p14="http://schemas.microsoft.com/office/powerpoint/2010/main" val="2008010650"/>
+        <p14:creationId xmlns:p14="http://schemas.microsoft.com/office/powerpoint/2010/main" val="3889236939"/>
       </p:ext>
     </p:extLst>
   </p:cSld>
@@ -2852,68 +2590,249 @@
           <a:chExt cx="0" cy="0"/>
         </a:xfrm>
       </p:grpSpPr>
-      <p:pic>
-        <p:nvPicPr>
-          <p:cNvPr id="4" name="Picture 3">
-            <a:extLst>
-              <a:ext uri="{FF2B5EF4-FFF2-40B4-BE49-F238E27FC236}">
-                <a16:creationId xmlns:a16="http://schemas.microsoft.com/office/drawing/2014/main" id="{218D4B93-2013-C01A-2FA0-35B26C773741}"/>
-              </a:ext>
-            </a:extLst>
-          </p:cNvPr>
-          <p:cNvPicPr>
-            <a:picLocks noChangeAspect="1"/>
-          </p:cNvPicPr>
-          <p:nvPr userDrawn="1"/>
-        </p:nvPicPr>
-        <p:blipFill>
-          <a:blip r:embed="rId13"/>
-          <a:stretch>
-            <a:fillRect/>
-          </a:stretch>
-        </p:blipFill>
+      <p:sp>
+        <p:nvSpPr>
+          <p:cNvPr id="2" name="Title Placeholder 1"/>
+          <p:cNvSpPr>
+            <a:spLocks noGrp="1"/>
+          </p:cNvSpPr>
+          <p:nvPr>
+            <p:ph type="title"/>
+          </p:nvPr>
+        </p:nvSpPr>
         <p:spPr>
           <a:xfrm>
-            <a:off x="19938" y="0"/>
-            <a:ext cx="21380262" cy="30275213"/>
+            <a:off x="457200" y="274638"/>
+            <a:ext cx="8229600" cy="1143000"/>
           </a:xfrm>
           <a:prstGeom prst="rect">
             <a:avLst/>
           </a:prstGeom>
         </p:spPr>
-      </p:pic>
+        <p:txBody>
+          <a:bodyPr vert="horz" lIns="91440" tIns="45720" rIns="91440" bIns="45720" rtlCol="0" anchor="ctr">
+            <a:normAutofit/>
+          </a:bodyPr>
+          <a:lstStyle/>
+          <a:p>
+            <a:r>
+              <a:rPr lang="en-US" smtClean="0"/>
+              <a:t>Click to edit Master title style</a:t>
+            </a:r>
+            <a:endParaRPr lang="en-US"/>
+          </a:p>
+        </p:txBody>
+      </p:sp>
+      <p:sp>
+        <p:nvSpPr>
+          <p:cNvPr id="3" name="Text Placeholder 2"/>
+          <p:cNvSpPr>
+            <a:spLocks noGrp="1"/>
+          </p:cNvSpPr>
+          <p:nvPr>
+            <p:ph type="body" idx="1"/>
+          </p:nvPr>
+        </p:nvSpPr>
+        <p:spPr>
+          <a:xfrm>
+            <a:off x="457200" y="1600200"/>
+            <a:ext cx="8229600" cy="4525963"/>
+          </a:xfrm>
+          <a:prstGeom prst="rect">
+            <a:avLst/>
+          </a:prstGeom>
+        </p:spPr>
+        <p:txBody>
+          <a:bodyPr vert="horz" lIns="91440" tIns="45720" rIns="91440" bIns="45720" rtlCol="0">
+            <a:normAutofit/>
+          </a:bodyPr>
+          <a:lstStyle/>
+          <a:p>
+            <a:pPr lvl="0"/>
+            <a:r>
+              <a:rPr lang="en-US" smtClean="0"/>
+              <a:t>Click to edit Master text styles</a:t>
+            </a:r>
+          </a:p>
+          <a:p>
+            <a:pPr lvl="1"/>
+            <a:r>
+              <a:rPr lang="en-US" smtClean="0"/>
+              <a:t>Second level</a:t>
+            </a:r>
+          </a:p>
+          <a:p>
+            <a:pPr lvl="2"/>
+            <a:r>
+              <a:rPr lang="en-US" smtClean="0"/>
+              <a:t>Third level</a:t>
+            </a:r>
+          </a:p>
+          <a:p>
+            <a:pPr lvl="3"/>
+            <a:r>
+              <a:rPr lang="en-US" smtClean="0"/>
+              <a:t>Fourth level</a:t>
+            </a:r>
+          </a:p>
+          <a:p>
+            <a:pPr lvl="4"/>
+            <a:r>
+              <a:rPr lang="en-US" smtClean="0"/>
+              <a:t>Fifth level</a:t>
+            </a:r>
+            <a:endParaRPr lang="en-US"/>
+          </a:p>
+        </p:txBody>
+      </p:sp>
+      <p:sp>
+        <p:nvSpPr>
+          <p:cNvPr id="4" name="Date Placeholder 3"/>
+          <p:cNvSpPr>
+            <a:spLocks noGrp="1"/>
+          </p:cNvSpPr>
+          <p:nvPr>
+            <p:ph type="dt" sz="half" idx="2"/>
+          </p:nvPr>
+        </p:nvSpPr>
+        <p:spPr>
+          <a:xfrm>
+            <a:off x="457200" y="6356350"/>
+            <a:ext cx="2133600" cy="365125"/>
+          </a:xfrm>
+          <a:prstGeom prst="rect">
+            <a:avLst/>
+          </a:prstGeom>
+        </p:spPr>
+        <p:txBody>
+          <a:bodyPr vert="horz" lIns="91440" tIns="45720" rIns="91440" bIns="45720" rtlCol="0" anchor="ctr"/>
+          <a:lstStyle>
+            <a:lvl1pPr algn="l">
+              <a:defRPr sz="1200">
+                <a:solidFill>
+                  <a:schemeClr val="tx1">
+                    <a:tint val="75000"/>
+                  </a:schemeClr>
+                </a:solidFill>
+              </a:defRPr>
+            </a:lvl1pPr>
+          </a:lstStyle>
+          <a:p>
+            <a:fld id="{5BCAD085-E8A6-8845-BD4E-CB4CCA059FC4}" type="datetimeFigureOut">
+              <a:rPr lang="en-US" smtClean="0"/>
+              <a:t>1/27/13</a:t>
+            </a:fld>
+            <a:endParaRPr lang="en-US"/>
+          </a:p>
+        </p:txBody>
+      </p:sp>
+      <p:sp>
+        <p:nvSpPr>
+          <p:cNvPr id="5" name="Footer Placeholder 4"/>
+          <p:cNvSpPr>
+            <a:spLocks noGrp="1"/>
+          </p:cNvSpPr>
+          <p:nvPr>
+            <p:ph type="ftr" sz="quarter" idx="3"/>
+          </p:nvPr>
+        </p:nvSpPr>
+        <p:spPr>
+          <a:xfrm>
+            <a:off x="3124200" y="6356350"/>
+            <a:ext cx="2895600" cy="365125"/>
+          </a:xfrm>
+          <a:prstGeom prst="rect">
+            <a:avLst/>
+          </a:prstGeom>
+        </p:spPr>
+        <p:txBody>
+          <a:bodyPr vert="horz" lIns="91440" tIns="45720" rIns="91440" bIns="45720" rtlCol="0" anchor="ctr"/>
+          <a:lstStyle>
+            <a:lvl1pPr algn="ctr">
+              <a:defRPr sz="1200">
+                <a:solidFill>
+                  <a:schemeClr val="tx1">
+                    <a:tint val="75000"/>
+                  </a:schemeClr>
+                </a:solidFill>
+              </a:defRPr>
+            </a:lvl1pPr>
+          </a:lstStyle>
+          <a:p>
+            <a:endParaRPr lang="en-US"/>
+          </a:p>
+        </p:txBody>
+      </p:sp>
+      <p:sp>
+        <p:nvSpPr>
+          <p:cNvPr id="6" name="Slide Number Placeholder 5"/>
+          <p:cNvSpPr>
+            <a:spLocks noGrp="1"/>
+          </p:cNvSpPr>
+          <p:nvPr>
+            <p:ph type="sldNum" sz="quarter" idx="4"/>
+          </p:nvPr>
+        </p:nvSpPr>
+        <p:spPr>
+          <a:xfrm>
+            <a:off x="6553200" y="6356350"/>
+            <a:ext cx="2133600" cy="365125"/>
+          </a:xfrm>
+          <a:prstGeom prst="rect">
+            <a:avLst/>
+          </a:prstGeom>
+        </p:spPr>
+        <p:txBody>
+          <a:bodyPr vert="horz" lIns="91440" tIns="45720" rIns="91440" bIns="45720" rtlCol="0" anchor="ctr"/>
+          <a:lstStyle>
+            <a:lvl1pPr algn="r">
+              <a:defRPr sz="1200">
+                <a:solidFill>
+                  <a:schemeClr val="tx1">
+                    <a:tint val="75000"/>
+                  </a:schemeClr>
+                </a:solidFill>
+              </a:defRPr>
+            </a:lvl1pPr>
+          </a:lstStyle>
+          <a:p>
+            <a:fld id="{C1FF6DA9-008F-8B48-92A6-B652298478BF}" type="slidenum">
+              <a:rPr lang="en-US" smtClean="0"/>
+              <a:t>‹#›</a:t>
+            </a:fld>
+            <a:endParaRPr lang="en-US"/>
+          </a:p>
+        </p:txBody>
+      </p:sp>
     </p:spTree>
     <p:extLst>
       <p:ext uri="{BB962C8B-B14F-4D97-AF65-F5344CB8AC3E}">
-        <p14:creationId xmlns:p14="http://schemas.microsoft.com/office/powerpoint/2010/main" val="730105992"/>
+        <p14:creationId xmlns:p14="http://schemas.microsoft.com/office/powerpoint/2010/main" val="2209977519"/>
       </p:ext>
     </p:extLst>
   </p:cSld>
   <p:clrMap bg1="lt1" tx1="dk1" bg2="lt2" tx2="dk2" accent1="accent1" accent2="accent2" accent3="accent3" accent4="accent4" accent5="accent5" accent6="accent6" hlink="hlink" folHlink="folHlink"/>
   <p:sldLayoutIdLst>
-    <p:sldLayoutId id="2147483661" r:id="rId1"/>
-    <p:sldLayoutId id="2147483662" r:id="rId2"/>
-    <p:sldLayoutId id="2147483663" r:id="rId3"/>
-    <p:sldLayoutId id="2147483664" r:id="rId4"/>
-    <p:sldLayoutId id="2147483665" r:id="rId5"/>
-    <p:sldLayoutId id="2147483666" r:id="rId6"/>
-    <p:sldLayoutId id="2147483667" r:id="rId7"/>
-    <p:sldLayoutId id="2147483668" r:id="rId8"/>
-    <p:sldLayoutId id="2147483669" r:id="rId9"/>
-    <p:sldLayoutId id="2147483670" r:id="rId10"/>
-    <p:sldLayoutId id="2147483671" r:id="rId11"/>
+    <p:sldLayoutId id="2147483649" r:id="rId1"/>
+    <p:sldLayoutId id="2147483650" r:id="rId2"/>
+    <p:sldLayoutId id="2147483651" r:id="rId3"/>
+    <p:sldLayoutId id="2147483652" r:id="rId4"/>
+    <p:sldLayoutId id="2147483653" r:id="rId5"/>
+    <p:sldLayoutId id="2147483654" r:id="rId6"/>
+    <p:sldLayoutId id="2147483655" r:id="rId7"/>
+    <p:sldLayoutId id="2147483656" r:id="rId8"/>
+    <p:sldLayoutId id="2147483657" r:id="rId9"/>
+    <p:sldLayoutId id="2147483658" r:id="rId10"/>
+    <p:sldLayoutId id="2147483659" r:id="rId11"/>
   </p:sldLayoutIdLst>
   <p:txStyles>
     <p:titleStyle>
-      <a:lvl1pPr algn="l" defTabSz="2141982" rtl="0" eaLnBrk="1" latinLnBrk="0" hangingPunct="1">
-        <a:lnSpc>
-          <a:spcPct val="90000"/>
-        </a:lnSpc>
+      <a:lvl1pPr algn="ctr" defTabSz="457200" rtl="0" eaLnBrk="1" latinLnBrk="0" hangingPunct="1">
         <a:spcBef>
           <a:spcPct val="0"/>
         </a:spcBef>
         <a:buNone/>
-        <a:defRPr sz="10307" kern="1200">
+        <a:defRPr sz="4400" kern="1200">
           <a:solidFill>
             <a:schemeClr val="tx1"/>
           </a:solidFill>
@@ -2924,16 +2843,13 @@
       </a:lvl1pPr>
     </p:titleStyle>
     <p:bodyStyle>
-      <a:lvl1pPr marL="535496" indent="-535496" algn="l" defTabSz="2141982" rtl="0" eaLnBrk="1" latinLnBrk="0" hangingPunct="1">
-        <a:lnSpc>
-          <a:spcPct val="90000"/>
-        </a:lnSpc>
+      <a:lvl1pPr marL="342900" indent="-342900" algn="l" defTabSz="457200" rtl="0" eaLnBrk="1" latinLnBrk="0" hangingPunct="1">
         <a:spcBef>
-          <a:spcPts val="2343"/>
+          <a:spcPct val="20000"/>
         </a:spcBef>
-        <a:buFont typeface="Arial" panose="020B0604020202020204" pitchFamily="34" charset="0"/>
+        <a:buFont typeface="Arial"/>
         <a:buChar char="•"/>
-        <a:defRPr sz="6559" kern="1200">
+        <a:defRPr sz="3200" kern="1200">
           <a:solidFill>
             <a:schemeClr val="tx1"/>
           </a:solidFill>
@@ -2942,16 +2858,13 @@
           <a:cs typeface="+mn-cs"/>
         </a:defRPr>
       </a:lvl1pPr>
-      <a:lvl2pPr marL="1606487" indent="-535496" algn="l" defTabSz="2141982" rtl="0" eaLnBrk="1" latinLnBrk="0" hangingPunct="1">
-        <a:lnSpc>
-          <a:spcPct val="90000"/>
-        </a:lnSpc>
+      <a:lvl2pPr marL="742950" indent="-285750" algn="l" defTabSz="457200" rtl="0" eaLnBrk="1" latinLnBrk="0" hangingPunct="1">
         <a:spcBef>
-          <a:spcPts val="1171"/>
+          <a:spcPct val="20000"/>
         </a:spcBef>
-        <a:buFont typeface="Arial" panose="020B0604020202020204" pitchFamily="34" charset="0"/>
-        <a:buChar char="•"/>
-        <a:defRPr sz="5622" kern="1200">
+        <a:buFont typeface="Arial"/>
+        <a:buChar char="–"/>
+        <a:defRPr sz="2800" kern="1200">
           <a:solidFill>
             <a:schemeClr val="tx1"/>
           </a:solidFill>
@@ -2960,16 +2873,13 @@
           <a:cs typeface="+mn-cs"/>
         </a:defRPr>
       </a:lvl2pPr>
-      <a:lvl3pPr marL="2677478" indent="-535496" algn="l" defTabSz="2141982" rtl="0" eaLnBrk="1" latinLnBrk="0" hangingPunct="1">
-        <a:lnSpc>
-          <a:spcPct val="90000"/>
-        </a:lnSpc>
+      <a:lvl3pPr marL="1143000" indent="-228600" algn="l" defTabSz="457200" rtl="0" eaLnBrk="1" latinLnBrk="0" hangingPunct="1">
         <a:spcBef>
-          <a:spcPts val="1171"/>
+          <a:spcPct val="20000"/>
         </a:spcBef>
-        <a:buFont typeface="Arial" panose="020B0604020202020204" pitchFamily="34" charset="0"/>
+        <a:buFont typeface="Arial"/>
         <a:buChar char="•"/>
-        <a:defRPr sz="4685" kern="1200">
+        <a:defRPr sz="2400" kern="1200">
           <a:solidFill>
             <a:schemeClr val="tx1"/>
           </a:solidFill>
@@ -2978,16 +2888,13 @@
           <a:cs typeface="+mn-cs"/>
         </a:defRPr>
       </a:lvl3pPr>
-      <a:lvl4pPr marL="3748469" indent="-535496" algn="l" defTabSz="2141982" rtl="0" eaLnBrk="1" latinLnBrk="0" hangingPunct="1">
-        <a:lnSpc>
-          <a:spcPct val="90000"/>
-        </a:lnSpc>
+      <a:lvl4pPr marL="1600200" indent="-228600" algn="l" defTabSz="457200" rtl="0" eaLnBrk="1" latinLnBrk="0" hangingPunct="1">
         <a:spcBef>
-          <a:spcPts val="1171"/>
+          <a:spcPct val="20000"/>
         </a:spcBef>
-        <a:buFont typeface="Arial" panose="020B0604020202020204" pitchFamily="34" charset="0"/>
-        <a:buChar char="•"/>
-        <a:defRPr sz="4217" kern="1200">
+        <a:buFont typeface="Arial"/>
+        <a:buChar char="–"/>
+        <a:defRPr sz="2000" kern="1200">
           <a:solidFill>
             <a:schemeClr val="tx1"/>
           </a:solidFill>
@@ -2996,16 +2903,13 @@
           <a:cs typeface="+mn-cs"/>
         </a:defRPr>
       </a:lvl4pPr>
-      <a:lvl5pPr marL="4819460" indent="-535496" algn="l" defTabSz="2141982" rtl="0" eaLnBrk="1" latinLnBrk="0" hangingPunct="1">
-        <a:lnSpc>
-          <a:spcPct val="90000"/>
-        </a:lnSpc>
+      <a:lvl5pPr marL="2057400" indent="-228600" algn="l" defTabSz="457200" rtl="0" eaLnBrk="1" latinLnBrk="0" hangingPunct="1">
         <a:spcBef>
-          <a:spcPts val="1171"/>
+          <a:spcPct val="20000"/>
         </a:spcBef>
-        <a:buFont typeface="Arial" panose="020B0604020202020204" pitchFamily="34" charset="0"/>
-        <a:buChar char="•"/>
-        <a:defRPr sz="4217" kern="1200">
+        <a:buFont typeface="Arial"/>
+        <a:buChar char="»"/>
+        <a:defRPr sz="2000" kern="1200">
           <a:solidFill>
             <a:schemeClr val="tx1"/>
           </a:solidFill>
@@ -3014,16 +2918,13 @@
           <a:cs typeface="+mn-cs"/>
         </a:defRPr>
       </a:lvl5pPr>
-      <a:lvl6pPr marL="5890451" indent="-535496" algn="l" defTabSz="2141982" rtl="0" eaLnBrk="1" latinLnBrk="0" hangingPunct="1">
-        <a:lnSpc>
-          <a:spcPct val="90000"/>
-        </a:lnSpc>
+      <a:lvl6pPr marL="2514600" indent="-228600" algn="l" defTabSz="457200" rtl="0" eaLnBrk="1" latinLnBrk="0" hangingPunct="1">
         <a:spcBef>
-          <a:spcPts val="1171"/>
+          <a:spcPct val="20000"/>
         </a:spcBef>
-        <a:buFont typeface="Arial" panose="020B0604020202020204" pitchFamily="34" charset="0"/>
+        <a:buFont typeface="Arial"/>
         <a:buChar char="•"/>
-        <a:defRPr sz="4217" kern="1200">
+        <a:defRPr sz="2000" kern="1200">
           <a:solidFill>
             <a:schemeClr val="tx1"/>
           </a:solidFill>
@@ -3032,16 +2933,13 @@
           <a:cs typeface="+mn-cs"/>
         </a:defRPr>
       </a:lvl6pPr>
-      <a:lvl7pPr marL="6961442" indent="-535496" algn="l" defTabSz="2141982" rtl="0" eaLnBrk="1" latinLnBrk="0" hangingPunct="1">
-        <a:lnSpc>
-          <a:spcPct val="90000"/>
-        </a:lnSpc>
+      <a:lvl7pPr marL="2971800" indent="-228600" algn="l" defTabSz="457200" rtl="0" eaLnBrk="1" latinLnBrk="0" hangingPunct="1">
         <a:spcBef>
-          <a:spcPts val="1171"/>
+          <a:spcPct val="20000"/>
         </a:spcBef>
-        <a:buFont typeface="Arial" panose="020B0604020202020204" pitchFamily="34" charset="0"/>
+        <a:buFont typeface="Arial"/>
         <a:buChar char="•"/>
-        <a:defRPr sz="4217" kern="1200">
+        <a:defRPr sz="2000" kern="1200">
           <a:solidFill>
             <a:schemeClr val="tx1"/>
           </a:solidFill>
@@ -3050,16 +2948,13 @@
           <a:cs typeface="+mn-cs"/>
         </a:defRPr>
       </a:lvl7pPr>
-      <a:lvl8pPr marL="8032433" indent="-535496" algn="l" defTabSz="2141982" rtl="0" eaLnBrk="1" latinLnBrk="0" hangingPunct="1">
-        <a:lnSpc>
-          <a:spcPct val="90000"/>
-        </a:lnSpc>
+      <a:lvl8pPr marL="3429000" indent="-228600" algn="l" defTabSz="457200" rtl="0" eaLnBrk="1" latinLnBrk="0" hangingPunct="1">
         <a:spcBef>
-          <a:spcPts val="1171"/>
+          <a:spcPct val="20000"/>
         </a:spcBef>
-        <a:buFont typeface="Arial" panose="020B0604020202020204" pitchFamily="34" charset="0"/>
+        <a:buFont typeface="Arial"/>
         <a:buChar char="•"/>
-        <a:defRPr sz="4217" kern="1200">
+        <a:defRPr sz="2000" kern="1200">
           <a:solidFill>
             <a:schemeClr val="tx1"/>
           </a:solidFill>
@@ -3068,16 +2963,13 @@
           <a:cs typeface="+mn-cs"/>
         </a:defRPr>
       </a:lvl8pPr>
-      <a:lvl9pPr marL="9103424" indent="-535496" algn="l" defTabSz="2141982" rtl="0" eaLnBrk="1" latinLnBrk="0" hangingPunct="1">
-        <a:lnSpc>
-          <a:spcPct val="90000"/>
-        </a:lnSpc>
+      <a:lvl9pPr marL="3886200" indent="-228600" algn="l" defTabSz="457200" rtl="0" eaLnBrk="1" latinLnBrk="0" hangingPunct="1">
         <a:spcBef>
-          <a:spcPts val="1171"/>
+          <a:spcPct val="20000"/>
         </a:spcBef>
-        <a:buFont typeface="Arial" panose="020B0604020202020204" pitchFamily="34" charset="0"/>
+        <a:buFont typeface="Arial"/>
         <a:buChar char="•"/>
-        <a:defRPr sz="4217" kern="1200">
+        <a:defRPr sz="2000" kern="1200">
           <a:solidFill>
             <a:schemeClr val="tx1"/>
           </a:solidFill>
@@ -3091,8 +2983,8 @@
       <a:defPPr>
         <a:defRPr lang="en-US"/>
       </a:defPPr>
-      <a:lvl1pPr marL="0" algn="l" defTabSz="2141982" rtl="0" eaLnBrk="1" latinLnBrk="0" hangingPunct="1">
-        <a:defRPr sz="4217" kern="1200">
+      <a:lvl1pPr marL="0" algn="l" defTabSz="457200" rtl="0" eaLnBrk="1" latinLnBrk="0" hangingPunct="1">
+        <a:defRPr sz="1800" kern="1200">
           <a:solidFill>
             <a:schemeClr val="tx1"/>
           </a:solidFill>
@@ -3101,8 +2993,8 @@
           <a:cs typeface="+mn-cs"/>
         </a:defRPr>
       </a:lvl1pPr>
-      <a:lvl2pPr marL="1070991" algn="l" defTabSz="2141982" rtl="0" eaLnBrk="1" latinLnBrk="0" hangingPunct="1">
-        <a:defRPr sz="4217" kern="1200">
+      <a:lvl2pPr marL="457200" algn="l" defTabSz="457200" rtl="0" eaLnBrk="1" latinLnBrk="0" hangingPunct="1">
+        <a:defRPr sz="1800" kern="1200">
           <a:solidFill>
             <a:schemeClr val="tx1"/>
           </a:solidFill>
@@ -3111,8 +3003,8 @@
           <a:cs typeface="+mn-cs"/>
         </a:defRPr>
       </a:lvl2pPr>
-      <a:lvl3pPr marL="2141982" algn="l" defTabSz="2141982" rtl="0" eaLnBrk="1" latinLnBrk="0" hangingPunct="1">
-        <a:defRPr sz="4217" kern="1200">
+      <a:lvl3pPr marL="914400" algn="l" defTabSz="457200" rtl="0" eaLnBrk="1" latinLnBrk="0" hangingPunct="1">
+        <a:defRPr sz="1800" kern="1200">
           <a:solidFill>
             <a:schemeClr val="tx1"/>
           </a:solidFill>
@@ -3121,8 +3013,8 @@
           <a:cs typeface="+mn-cs"/>
         </a:defRPr>
       </a:lvl3pPr>
-      <a:lvl4pPr marL="3212973" algn="l" defTabSz="2141982" rtl="0" eaLnBrk="1" latinLnBrk="0" hangingPunct="1">
-        <a:defRPr sz="4217" kern="1200">
+      <a:lvl4pPr marL="1371600" algn="l" defTabSz="457200" rtl="0" eaLnBrk="1" latinLnBrk="0" hangingPunct="1">
+        <a:defRPr sz="1800" kern="1200">
           <a:solidFill>
             <a:schemeClr val="tx1"/>
           </a:solidFill>
@@ -3131,8 +3023,8 @@
           <a:cs typeface="+mn-cs"/>
         </a:defRPr>
       </a:lvl4pPr>
-      <a:lvl5pPr marL="4283964" algn="l" defTabSz="2141982" rtl="0" eaLnBrk="1" latinLnBrk="0" hangingPunct="1">
-        <a:defRPr sz="4217" kern="1200">
+      <a:lvl5pPr marL="1828800" algn="l" defTabSz="457200" rtl="0" eaLnBrk="1" latinLnBrk="0" hangingPunct="1">
+        <a:defRPr sz="1800" kern="1200">
           <a:solidFill>
             <a:schemeClr val="tx1"/>
           </a:solidFill>
@@ -3141,8 +3033,8 @@
           <a:cs typeface="+mn-cs"/>
         </a:defRPr>
       </a:lvl5pPr>
-      <a:lvl6pPr marL="5354955" algn="l" defTabSz="2141982" rtl="0" eaLnBrk="1" latinLnBrk="0" hangingPunct="1">
-        <a:defRPr sz="4217" kern="1200">
+      <a:lvl6pPr marL="2286000" algn="l" defTabSz="457200" rtl="0" eaLnBrk="1" latinLnBrk="0" hangingPunct="1">
+        <a:defRPr sz="1800" kern="1200">
           <a:solidFill>
             <a:schemeClr val="tx1"/>
           </a:solidFill>
@@ -3151,8 +3043,8 @@
           <a:cs typeface="+mn-cs"/>
         </a:defRPr>
       </a:lvl6pPr>
-      <a:lvl7pPr marL="6425946" algn="l" defTabSz="2141982" rtl="0" eaLnBrk="1" latinLnBrk="0" hangingPunct="1">
-        <a:defRPr sz="4217" kern="1200">
+      <a:lvl7pPr marL="2743200" algn="l" defTabSz="457200" rtl="0" eaLnBrk="1" latinLnBrk="0" hangingPunct="1">
+        <a:defRPr sz="1800" kern="1200">
           <a:solidFill>
             <a:schemeClr val="tx1"/>
           </a:solidFill>
@@ -3161,8 +3053,8 @@
           <a:cs typeface="+mn-cs"/>
         </a:defRPr>
       </a:lvl7pPr>
-      <a:lvl8pPr marL="7496937" algn="l" defTabSz="2141982" rtl="0" eaLnBrk="1" latinLnBrk="0" hangingPunct="1">
-        <a:defRPr sz="4217" kern="1200">
+      <a:lvl8pPr marL="3200400" algn="l" defTabSz="457200" rtl="0" eaLnBrk="1" latinLnBrk="0" hangingPunct="1">
+        <a:defRPr sz="1800" kern="1200">
           <a:solidFill>
             <a:schemeClr val="tx1"/>
           </a:solidFill>
@@ -3171,8 +3063,8 @@
           <a:cs typeface="+mn-cs"/>
         </a:defRPr>
       </a:lvl8pPr>
-      <a:lvl9pPr marL="8567928" algn="l" defTabSz="2141982" rtl="0" eaLnBrk="1" latinLnBrk="0" hangingPunct="1">
-        <a:defRPr sz="4217" kern="1200">
+      <a:lvl9pPr marL="3657600" algn="l" defTabSz="457200" rtl="0" eaLnBrk="1" latinLnBrk="0" hangingPunct="1">
+        <a:defRPr sz="1800" kern="1200">
           <a:solidFill>
             <a:schemeClr val="tx1"/>
           </a:solidFill>
@@ -3187,7 +3079,7 @@
 </file>
 
 <file path=ppt/slides/slide1.xml><?xml version="1.0" encoding="utf-8"?>
-<p:sld xmlns:a="http://schemas.openxmlformats.org/drawingml/2006/main" xmlns:r="http://schemas.openxmlformats.org/officeDocument/2006/relationships" xmlns:p="http://schemas.openxmlformats.org/presentationml/2006/main">
+<p:sld xmlns:a="http://schemas.openxmlformats.org/drawingml/2006/main" xmlns:p="http://schemas.openxmlformats.org/presentationml/2006/main" xmlns:r="http://schemas.openxmlformats.org/officeDocument/2006/relationships">
   <p:cSld>
     <p:spTree>
       <p:nvGrpSpPr>
@@ -3195,14 +3087,7 @@
         <p:cNvGrpSpPr/>
         <p:nvPr/>
       </p:nvGrpSpPr>
-      <p:grpSpPr>
-        <a:xfrm>
-          <a:off x="0" y="0"/>
-          <a:ext cx="0" cy="0"/>
-          <a:chOff x="0" y="0"/>
-          <a:chExt cx="0" cy="0"/>
-        </a:xfrm>
-      </p:grpSpPr>
+      <p:grpSpPr/>
       <p:pic>
         <p:nvPicPr>
           <p:cNvPr id="2" name="Picture 1" descr="MentorMinds-DIGITEX2026-poster.png"/>
@@ -3220,7 +3105,7 @@
         <p:spPr>
           <a:xfrm>
             <a:off x="0" y="0"/>
-            <a:ext cx="21420138" cy="30275213"/>
+            <a:ext cx="21384000" cy="30276000"/>
           </a:xfrm>
           <a:prstGeom prst="rect">
             <a:avLst/>
@@ -3228,11 +3113,6 @@
         </p:spPr>
       </p:pic>
     </p:spTree>
-    <p:extLst>
-      <p:ext uri="{BB962C8B-B14F-4D97-AF65-F5344CB8AC3E}">
-        <p14:creationId xmlns:p14="http://schemas.microsoft.com/office/powerpoint/2010/main" val="2131922519"/>
-      </p:ext>
-    </p:extLst>
   </p:cSld>
   <p:clrMapOvr>
     <a:masterClrMapping/>
@@ -3243,7 +3123,7 @@
 <file path=ppt/theme/theme1.xml><?xml version="1.0" encoding="utf-8"?>
 <a:theme xmlns:a="http://schemas.openxmlformats.org/drawingml/2006/main" name="Office Theme">
   <a:themeElements>
-    <a:clrScheme name="Office Theme">
+    <a:clrScheme name="Office">
       <a:dk1>
         <a:sysClr val="windowText" lastClr="000000"/>
       </a:dk1>
@@ -3251,44 +3131,44 @@
         <a:sysClr val="window" lastClr="FFFFFF"/>
       </a:lt1>
       <a:dk2>
-        <a:srgbClr val="0E2841"/>
+        <a:srgbClr val="1F497D"/>
       </a:dk2>
       <a:lt2>
-        <a:srgbClr val="E8E8E8"/>
+        <a:srgbClr val="EEECE1"/>
       </a:lt2>
       <a:accent1>
-        <a:srgbClr val="156082"/>
+        <a:srgbClr val="4F81BD"/>
       </a:accent1>
       <a:accent2>
-        <a:srgbClr val="E97132"/>
+        <a:srgbClr val="C0504D"/>
       </a:accent2>
       <a:accent3>
-        <a:srgbClr val="196B24"/>
+        <a:srgbClr val="9BBB59"/>
       </a:accent3>
       <a:accent4>
-        <a:srgbClr val="0F9ED5"/>
+        <a:srgbClr val="8064A2"/>
       </a:accent4>
       <a:accent5>
-        <a:srgbClr val="A02B93"/>
+        <a:srgbClr val="4BACC6"/>
       </a:accent5>
       <a:accent6>
-        <a:srgbClr val="4EA72E"/>
+        <a:srgbClr val="F79646"/>
       </a:accent6>
       <a:hlink>
-        <a:srgbClr val="467886"/>
+        <a:srgbClr val="0000FF"/>
       </a:hlink>
       <a:folHlink>
-        <a:srgbClr val="96607D"/>
+        <a:srgbClr val="800080"/>
       </a:folHlink>
     </a:clrScheme>
-    <a:fontScheme name="Office Theme">
+    <a:fontScheme name="Office">
       <a:majorFont>
-        <a:latin typeface="Aptos Display" panose="02110004020202020204"/>
+        <a:latin typeface="Calibri"/>
         <a:ea typeface=""/>
         <a:cs typeface=""/>
-        <a:font script="Jpan" typeface="游ゴシック Light"/>
+        <a:font script="Jpan" typeface="ＭＳ Ｐゴシック"/>
         <a:font script="Hang" typeface="맑은 고딕"/>
-        <a:font script="Hans" typeface="等线 Light"/>
+        <a:font script="Hans" typeface="宋体"/>
         <a:font script="Hant" typeface="新細明體"/>
         <a:font script="Arab" typeface="Times New Roman"/>
         <a:font script="Hebr" typeface="Times New Roman"/>
@@ -3316,31 +3196,14 @@
         <a:font script="Viet" typeface="Times New Roman"/>
         <a:font script="Uigh" typeface="Microsoft Uighur"/>
         <a:font script="Geor" typeface="Sylfaen"/>
-        <a:font script="Armn" typeface="Arial"/>
-        <a:font script="Bugi" typeface="Leelawadee UI"/>
-        <a:font script="Bopo" typeface="Microsoft JhengHei"/>
-        <a:font script="Java" typeface="Javanese Text"/>
-        <a:font script="Lisu" typeface="Segoe UI"/>
-        <a:font script="Mymr" typeface="Myanmar Text"/>
-        <a:font script="Nkoo" typeface="Ebrima"/>
-        <a:font script="Olck" typeface="Nirmala UI"/>
-        <a:font script="Osma" typeface="Ebrima"/>
-        <a:font script="Phag" typeface="Phagspa"/>
-        <a:font script="Syrn" typeface="Estrangelo Edessa"/>
-        <a:font script="Syrj" typeface="Estrangelo Edessa"/>
-        <a:font script="Syre" typeface="Estrangelo Edessa"/>
-        <a:font script="Sora" typeface="Nirmala UI"/>
-        <a:font script="Tale" typeface="Microsoft Tai Le"/>
-        <a:font script="Talu" typeface="Microsoft New Tai Lue"/>
-        <a:font script="Tfng" typeface="Ebrima"/>
       </a:majorFont>
       <a:minorFont>
-        <a:latin typeface="Aptos" panose="02110004020202020204"/>
+        <a:latin typeface="Calibri"/>
         <a:ea typeface=""/>
         <a:cs typeface=""/>
-        <a:font script="Jpan" typeface="游ゴシック"/>
+        <a:font script="Jpan" typeface="ＭＳ Ｐゴシック"/>
         <a:font script="Hang" typeface="맑은 고딕"/>
-        <a:font script="Hans" typeface="等线"/>
+        <a:font script="Hans" typeface="宋体"/>
         <a:font script="Hant" typeface="新細明體"/>
         <a:font script="Arab" typeface="Arial"/>
         <a:font script="Hebr" typeface="Arial"/>
@@ -3368,26 +3231,9 @@
         <a:font script="Viet" typeface="Arial"/>
         <a:font script="Uigh" typeface="Microsoft Uighur"/>
         <a:font script="Geor" typeface="Sylfaen"/>
-        <a:font script="Armn" typeface="Arial"/>
-        <a:font script="Bugi" typeface="Leelawadee UI"/>
-        <a:font script="Bopo" typeface="Microsoft JhengHei"/>
-        <a:font script="Java" typeface="Javanese Text"/>
-        <a:font script="Lisu" typeface="Segoe UI"/>
-        <a:font script="Mymr" typeface="Myanmar Text"/>
-        <a:font script="Nkoo" typeface="Ebrima"/>
-        <a:font script="Olck" typeface="Nirmala UI"/>
-        <a:font script="Osma" typeface="Ebrima"/>
-        <a:font script="Phag" typeface="Phagspa"/>
-        <a:font script="Syrn" typeface="Estrangelo Edessa"/>
-        <a:font script="Syrj" typeface="Estrangelo Edessa"/>
-        <a:font script="Syre" typeface="Estrangelo Edessa"/>
-        <a:font script="Sora" typeface="Nirmala UI"/>
-        <a:font script="Tale" typeface="Microsoft Tai Le"/>
-        <a:font script="Talu" typeface="Microsoft New Tai Lue"/>
-        <a:font script="Tfng" typeface="Ebrima"/>
       </a:minorFont>
     </a:fontScheme>
-    <a:fmtScheme name="Office Theme">
+    <a:fmtScheme name="Office">
       <a:fillStyleLst>
         <a:solidFill>
           <a:schemeClr val="phClr"/>
@@ -3396,136 +3242,180 @@
           <a:gsLst>
             <a:gs pos="0">
               <a:schemeClr val="phClr">
-                <a:lumMod val="110000"/>
-                <a:satMod val="105000"/>
-                <a:tint val="67000"/>
+                <a:tint val="50000"/>
+                <a:satMod val="300000"/>
               </a:schemeClr>
             </a:gs>
-            <a:gs pos="50000">
+            <a:gs pos="35000">
               <a:schemeClr val="phClr">
-                <a:lumMod val="105000"/>
-                <a:satMod val="103000"/>
-                <a:tint val="73000"/>
+                <a:tint val="37000"/>
+                <a:satMod val="300000"/>
               </a:schemeClr>
             </a:gs>
             <a:gs pos="100000">
               <a:schemeClr val="phClr">
-                <a:lumMod val="105000"/>
-                <a:satMod val="109000"/>
-                <a:tint val="81000"/>
+                <a:tint val="15000"/>
+                <a:satMod val="350000"/>
               </a:schemeClr>
             </a:gs>
           </a:gsLst>
-          <a:lin ang="5400000" scaled="0"/>
+          <a:lin ang="16200000" scaled="1"/>
         </a:gradFill>
         <a:gradFill rotWithShape="1">
           <a:gsLst>
             <a:gs pos="0">
               <a:schemeClr val="phClr">
-                <a:satMod val="103000"/>
-                <a:lumMod val="102000"/>
-                <a:tint val="94000"/>
-              </a:schemeClr>
-            </a:gs>
-            <a:gs pos="50000">
-              <a:schemeClr val="phClr">
-                <a:satMod val="110000"/>
-                <a:lumMod val="100000"/>
+                <a:tint val="100000"/>
                 <a:shade val="100000"/>
+                <a:satMod val="130000"/>
               </a:schemeClr>
             </a:gs>
             <a:gs pos="100000">
               <a:schemeClr val="phClr">
-                <a:lumMod val="99000"/>
-                <a:satMod val="120000"/>
-                <a:shade val="78000"/>
+                <a:tint val="50000"/>
+                <a:shade val="100000"/>
+                <a:satMod val="350000"/>
               </a:schemeClr>
             </a:gs>
           </a:gsLst>
-          <a:lin ang="5400000" scaled="0"/>
+          <a:lin ang="16200000" scaled="0"/>
         </a:gradFill>
       </a:fillStyleLst>
       <a:lnStyleLst>
-        <a:ln w="12700" cap="flat" cmpd="sng" algn="ctr">
+        <a:ln w="9525" cap="flat" cmpd="sng" algn="ctr">
           <a:solidFill>
-            <a:schemeClr val="phClr"/>
+            <a:schemeClr val="phClr">
+              <a:shade val="95000"/>
+              <a:satMod val="105000"/>
+            </a:schemeClr>
           </a:solidFill>
           <a:prstDash val="solid"/>
-          <a:miter lim="800000"/>
-        </a:ln>
-        <a:ln w="19050" cap="flat" cmpd="sng" algn="ctr">
-          <a:solidFill>
-            <a:schemeClr val="phClr"/>
-          </a:solidFill>
-          <a:prstDash val="solid"/>
-          <a:miter lim="800000"/>
         </a:ln>
         <a:ln w="25400" cap="flat" cmpd="sng" algn="ctr">
           <a:solidFill>
             <a:schemeClr val="phClr"/>
           </a:solidFill>
           <a:prstDash val="solid"/>
-          <a:miter lim="800000"/>
+        </a:ln>
+        <a:ln w="38100" cap="flat" cmpd="sng" algn="ctr">
+          <a:solidFill>
+            <a:schemeClr val="phClr"/>
+          </a:solidFill>
+          <a:prstDash val="solid"/>
         </a:ln>
       </a:lnStyleLst>
       <a:effectStyleLst>
         <a:effectStyle>
-          <a:effectLst/>
-        </a:effectStyle>
-        <a:effectStyle>
-          <a:effectLst/>
+          <a:effectLst>
+            <a:outerShdw blurRad="40000" dist="20000" dir="5400000" rotWithShape="0">
+              <a:srgbClr val="000000">
+                <a:alpha val="38000"/>
+              </a:srgbClr>
+            </a:outerShdw>
+          </a:effectLst>
         </a:effectStyle>
         <a:effectStyle>
           <a:effectLst>
-            <a:outerShdw blurRad="57150" dist="19050" dir="5400000" algn="ctr" rotWithShape="0">
+            <a:outerShdw blurRad="40000" dist="23000" dir="5400000" rotWithShape="0">
               <a:srgbClr val="000000">
-                <a:alpha val="63000"/>
+                <a:alpha val="35000"/>
               </a:srgbClr>
             </a:outerShdw>
           </a:effectLst>
+        </a:effectStyle>
+        <a:effectStyle>
+          <a:effectLst>
+            <a:outerShdw blurRad="40000" dist="23000" dir="5400000" rotWithShape="0">
+              <a:srgbClr val="000000">
+                <a:alpha val="35000"/>
+              </a:srgbClr>
+            </a:outerShdw>
+          </a:effectLst>
+          <a:scene3d>
+            <a:camera prst="orthographicFront">
+              <a:rot lat="0" lon="0" rev="0"/>
+            </a:camera>
+            <a:lightRig rig="threePt" dir="t">
+              <a:rot lat="0" lon="0" rev="1200000"/>
+            </a:lightRig>
+          </a:scene3d>
+          <a:sp3d>
+            <a:bevelT w="63500" h="25400"/>
+          </a:sp3d>
         </a:effectStyle>
       </a:effectStyleLst>
       <a:bgFillStyleLst>
         <a:solidFill>
           <a:schemeClr val="phClr"/>
         </a:solidFill>
-        <a:solidFill>
-          <a:schemeClr val="phClr">
-            <a:tint val="95000"/>
-            <a:satMod val="170000"/>
-          </a:schemeClr>
-        </a:solidFill>
         <a:gradFill rotWithShape="1">
           <a:gsLst>
             <a:gs pos="0">
               <a:schemeClr val="phClr">
-                <a:tint val="93000"/>
-                <a:satMod val="150000"/>
-                <a:shade val="98000"/>
-                <a:lumMod val="102000"/>
+                <a:tint val="40000"/>
+                <a:satMod val="350000"/>
               </a:schemeClr>
             </a:gs>
-            <a:gs pos="50000">
+            <a:gs pos="40000">
               <a:schemeClr val="phClr">
-                <a:tint val="98000"/>
-                <a:satMod val="130000"/>
-                <a:shade val="90000"/>
-                <a:lumMod val="103000"/>
+                <a:tint val="45000"/>
+                <a:shade val="99000"/>
+                <a:satMod val="350000"/>
               </a:schemeClr>
             </a:gs>
             <a:gs pos="100000">
               <a:schemeClr val="phClr">
-                <a:shade val="63000"/>
-                <a:satMod val="120000"/>
+                <a:shade val="20000"/>
+                <a:satMod val="255000"/>
               </a:schemeClr>
             </a:gs>
           </a:gsLst>
-          <a:lin ang="5400000" scaled="0"/>
+          <a:path path="circle">
+            <a:fillToRect l="50000" t="-80000" r="50000" b="180000"/>
+          </a:path>
+        </a:gradFill>
+        <a:gradFill rotWithShape="1">
+          <a:gsLst>
+            <a:gs pos="0">
+              <a:schemeClr val="phClr">
+                <a:tint val="80000"/>
+                <a:satMod val="300000"/>
+              </a:schemeClr>
+            </a:gs>
+            <a:gs pos="100000">
+              <a:schemeClr val="phClr">
+                <a:shade val="30000"/>
+                <a:satMod val="200000"/>
+              </a:schemeClr>
+            </a:gs>
+          </a:gsLst>
+          <a:path path="circle">
+            <a:fillToRect l="50000" t="50000" r="50000" b="50000"/>
+          </a:path>
         </a:gradFill>
       </a:bgFillStyleLst>
     </a:fmtScheme>
   </a:themeElements>
   <a:objectDefaults>
+    <a:spDef>
+      <a:spPr/>
+      <a:bodyPr/>
+      <a:lstStyle/>
+      <a:style>
+        <a:lnRef idx="1">
+          <a:schemeClr val="accent1"/>
+        </a:lnRef>
+        <a:fillRef idx="3">
+          <a:schemeClr val="accent1"/>
+        </a:fillRef>
+        <a:effectRef idx="2">
+          <a:schemeClr val="accent1"/>
+        </a:effectRef>
+        <a:fontRef idx="minor">
+          <a:schemeClr val="lt1"/>
+        </a:fontRef>
+      </a:style>
+    </a:spDef>
     <a:lnDef>
       <a:spPr/>
       <a:bodyPr/>
@@ -3547,10 +3437,5 @@
     </a:lnDef>
   </a:objectDefaults>
   <a:extraClrSchemeLst/>
-  <a:extLst>
-    <a:ext uri="{05A4C25C-085E-4340-85A3-A5531E510DB2}">
-      <thm15:themeFamily xmlns:thm15="http://schemas.microsoft.com/office/thememl/2012/main" name="Office Theme" id="{2E142A2C-CD16-42D6-873A-C26D2A0506FA}" vid="{1BDDFF52-6CD6-40A5-AB3C-68EB2F1E4D0A}"/>
-    </a:ext>
-  </a:extLst>
 </a:theme>
 </file>
</xml_diff>